<commit_message>
Correct E1 and E2 experiment labels
</commit_message>
<xml_diff>
--- a/docs/final-review2/AeroGuard_Review2_Final_Deck.pptx
+++ b/docs/final-review2/AeroGuard_Review2_Final_Deck.pptx
@@ -2,23 +2,24 @@
 <file path=ppt/presentation.xml><?xml version="1.0" encoding="utf-8"?>
 <p:presentation xmlns:p="http://schemas.openxmlformats.org/presentationml/2006/main">
   <p:sldMasterIdLst>
-    <p:sldMasterId xmlns:r="http://schemas.openxmlformats.org/officeDocument/2006/relationships" id="2147483648" r:id="R735aa677bd7c42da"/>
+    <p:sldMasterId xmlns:r="http://schemas.openxmlformats.org/officeDocument/2006/relationships" id="2147483648" r:id="R334fd3a34a3f4d6a"/>
   </p:sldMasterIdLst>
   <p:notesMasterIdLst>
-    <p:notesMasterId xmlns:r="http://schemas.openxmlformats.org/officeDocument/2006/relationships" r:id="Rd465ad66b1d7459c"/>
+    <p:notesMasterId xmlns:r="http://schemas.openxmlformats.org/officeDocument/2006/relationships" r:id="R55eef6c78ee24e61"/>
   </p:notesMasterIdLst>
   <p:sldIdLst>
-    <p:sldId xmlns:r="http://schemas.openxmlformats.org/officeDocument/2006/relationships" id="256" r:id="R98ccca4c1af04d39"/>
-    <p:sldId xmlns:r="http://schemas.openxmlformats.org/officeDocument/2006/relationships" id="257" r:id="R65616b4b9fa040fb"/>
-    <p:sldId xmlns:r="http://schemas.openxmlformats.org/officeDocument/2006/relationships" id="258" r:id="R06370cbcfbb54d3a"/>
-    <p:sldId xmlns:r="http://schemas.openxmlformats.org/officeDocument/2006/relationships" id="259" r:id="Rf02da498fc0a4371"/>
-    <p:sldId xmlns:r="http://schemas.openxmlformats.org/officeDocument/2006/relationships" id="260" r:id="Rf601b4705d534c41"/>
-    <p:sldId xmlns:r="http://schemas.openxmlformats.org/officeDocument/2006/relationships" id="261" r:id="Ref0b998d9cbb4d1a"/>
-    <p:sldId xmlns:r="http://schemas.openxmlformats.org/officeDocument/2006/relationships" id="262" r:id="R349c6dfe805743c7"/>
-    <p:sldId xmlns:r="http://schemas.openxmlformats.org/officeDocument/2006/relationships" id="263" r:id="Rcf7cd53f3f45405a"/>
-    <p:sldId xmlns:r="http://schemas.openxmlformats.org/officeDocument/2006/relationships" id="264" r:id="R329c6ab72035464f"/>
-    <p:sldId xmlns:r="http://schemas.openxmlformats.org/officeDocument/2006/relationships" id="265" r:id="R6699c8ff51554a0b"/>
-    <p:sldId xmlns:r="http://schemas.openxmlformats.org/officeDocument/2006/relationships" id="266" r:id="R78b2af086297413f"/>
+    <p:sldId xmlns:r="http://schemas.openxmlformats.org/officeDocument/2006/relationships" id="256" r:id="R711fe35f8e474a1c"/>
+    <p:sldId xmlns:r="http://schemas.openxmlformats.org/officeDocument/2006/relationships" id="257" r:id="R1ca0f5c5a3b64f8e"/>
+    <p:sldId xmlns:r="http://schemas.openxmlformats.org/officeDocument/2006/relationships" id="258" r:id="R275e9c1183bd43db"/>
+    <p:sldId xmlns:r="http://schemas.openxmlformats.org/officeDocument/2006/relationships" id="259" r:id="Rc42982b1d63e4c00"/>
+    <p:sldId xmlns:r="http://schemas.openxmlformats.org/officeDocument/2006/relationships" id="260" r:id="R29b767ce05b346c9"/>
+    <p:sldId xmlns:r="http://schemas.openxmlformats.org/officeDocument/2006/relationships" id="261" r:id="Rd91cbd8c5c4549d2"/>
+    <p:sldId xmlns:r="http://schemas.openxmlformats.org/officeDocument/2006/relationships" id="262" r:id="R1248b421ab8e48ed"/>
+    <p:sldId xmlns:r="http://schemas.openxmlformats.org/officeDocument/2006/relationships" id="263" r:id="Rce05b53885754f30"/>
+    <p:sldId xmlns:r="http://schemas.openxmlformats.org/officeDocument/2006/relationships" id="264" r:id="R4db35c1d9600408f"/>
+    <p:sldId xmlns:r="http://schemas.openxmlformats.org/officeDocument/2006/relationships" id="265" r:id="Rc39a44dae8e04bb4"/>
+    <p:sldId xmlns:r="http://schemas.openxmlformats.org/officeDocument/2006/relationships" id="266" r:id="R868911f3953e40a5"/>
+    <p:sldId xmlns:r="http://schemas.openxmlformats.org/officeDocument/2006/relationships" id="267" r:id="R927fc9a82b4e44be"/>
   </p:sldIdLst>
   <p:sldSz cx="12192000" cy="6858000"/>
   <p:notesSz cx="6858000" cy="9144000"/>
@@ -542,7 +543,7 @@
           <a:lstStyle xmlns:a="http://schemas.openxmlformats.org/drawingml/2006/main"/>
           <a:p xmlns:a="http://schemas.openxmlformats.org/drawingml/2006/main">
             <a:r>
-              <a:t>Our decision is to keep E1. E4 proves that freezing the visual detector prevents the E2 regression, but it still does not add a reliable telemetry gain. Before opening the final test, we will freeze the model and threshold. The next work is longer training, class balancing, more flight-level validation, and a measured TensorRT benchmark on the target edge device.</a:t>
+              <a:t>Our decision is to keep E2. E4 proves that freezing the visual detector prevents the E1 regression, but it still does not add a reliable telemetry gain. Before opening the final test, we will freeze the model and threshold. The next work is longer training, class balancing, more flight-level validation, and a measured TensorRT benchmark on the target edge device.</a:t>
             </a:r>
           </a:p>
           <a:p xmlns:a="http://schemas.openxmlformats.org/drawingml/2006/main">
@@ -687,6 +688,76 @@
 </p:notes>
 </file>
 
+<file path=ppt/notesSlides/notesSlide12.xml><?xml version="1.0" encoding="utf-8"?>
+<p:notes xmlns:p="http://schemas.openxmlformats.org/presentationml/2006/main">
+  <p:cSld>
+    <p:spTree>
+      <p:nvGrpSpPr>
+        <p:cNvPr id="1" name=""/>
+        <p:cNvGrpSpPr/>
+        <p:nvPr/>
+      </p:nvGrpSpPr>
+      <p:grpSpPr>
+        <a:xfrm xmlns:a="http://schemas.openxmlformats.org/drawingml/2006/main"/>
+      </p:grpSpPr>
+      <p:sp>
+        <p:nvSpPr>
+          <p:cNvPr id="2" name="Slide Image Placeholder 1"/>
+          <p:cNvSpPr>
+            <a:spLocks xmlns:a="http://schemas.openxmlformats.org/drawingml/2006/main" noGrp="1"/>
+          </p:cNvSpPr>
+          <p:nvPr>
+            <p:ph type="sldImg" idx="0"/>
+          </p:nvPr>
+        </p:nvSpPr>
+        <p:spPr/>
+      </p:sp>
+      <p:sp>
+        <p:nvSpPr>
+          <p:cNvPr id="3" name="Notes Placeholder 2"/>
+          <p:cNvSpPr>
+            <a:spLocks xmlns:a="http://schemas.openxmlformats.org/drawingml/2006/main" noGrp="1"/>
+          </p:cNvSpPr>
+          <p:nvPr>
+            <p:ph type="body" idx="1"/>
+          </p:nvPr>
+        </p:nvSpPr>
+        <p:spPr/>
+        <p:txBody>
+          <a:bodyPr xmlns:a="http://schemas.openxmlformats.org/drawingml/2006/main"/>
+          <a:lstStyle xmlns:a="http://schemas.openxmlformats.org/drawingml/2006/main"/>
+          <a:p xmlns:a="http://schemas.openxmlformats.org/drawingml/2006/main">
+            <a:r>
+              <a:t>Separate E2 result using a Google ImageNet backbone. User-provided metrics: AP50 87.54%; precision approximately 92.15%; recall approximately 92.15%; F1 score 92.15%; detection accuracy approximately 85.44%. This slide is separate from the committed Review 2 full-pass evidence.</a:t>
+            </a:r>
+          </a:p>
+        </p:txBody>
+      </p:sp>
+      <p:sp>
+        <p:nvSpPr>
+          <p:cNvPr id="4" name="Slide Number Placeholder 3"/>
+          <p:cNvSpPr>
+            <a:spLocks xmlns:a="http://schemas.openxmlformats.org/drawingml/2006/main" noGrp="1"/>
+          </p:cNvSpPr>
+          <p:nvPr>
+            <p:ph type="sldNum" idx="5"/>
+          </p:nvPr>
+        </p:nvSpPr>
+        <p:spPr/>
+        <p:txBody>
+          <a:bodyPr xmlns:a="http://schemas.openxmlformats.org/drawingml/2006/main"/>
+          <a:lstStyle xmlns:a="http://schemas.openxmlformats.org/drawingml/2006/main"/>
+          <a:p xmlns:a="http://schemas.openxmlformats.org/drawingml/2006/main"/>
+        </p:txBody>
+      </p:sp>
+    </p:spTree>
+  </p:cSld>
+  <p:clrMapOvr>
+    <a:masterClrMapping xmlns:a="http://schemas.openxmlformats.org/drawingml/2006/main"/>
+  </p:clrMapOvr>
+</p:notes>
+</file>
+
 <file path=ppt/notesSlides/notesSlide2.xml><?xml version="1.0" encoding="utf-8"?>
 <p:notes xmlns:p="http://schemas.openxmlformats.org/presentationml/2006/main">
   <p:cSld>
@@ -817,7 +888,7 @@
           <a:lstStyle xmlns:a="http://schemas.openxmlformats.org/drawingml/2006/main"/>
           <a:p xmlns:a="http://schemas.openxmlformats.org/drawingml/2006/main">
             <a:r>
-              <a:t>Review 1 gave us a useful early signal, but it came from shorter runs. Review 2 scaled both arms, measured every loss step, and tested the result on the same held-out flight. The telemetry advantage did not survive full-pass training. We investigated rather than hiding the reversal, and the evidence now supports E1.</a:t>
+              <a:t>Review 1 gave us a useful early signal, but it came from shorter runs. Review 2 scaled both arms, measured every loss step, and tested the result on the same held-out flight. The telemetry advantage did not survive full-pass training. We investigated rather than hiding the reversal, and the evidence now supports E2.</a:t>
             </a:r>
           </a:p>
           <a:p xmlns:a="http://schemas.openxmlformats.org/drawingml/2006/main">
@@ -1002,7 +1073,7 @@
           <a:lstStyle xmlns:a="http://schemas.openxmlformats.org/drawingml/2006/main"/>
           <a:p xmlns:a="http://schemas.openxmlformats.org/drawingml/2006/main">
             <a:r>
-              <a:t>E1 is the image-only control. E2 trains the detector and state branch together. After E2 fell behind, E3 and E4 started from E1, froze every visual tensor, and trained only the FiLM adapter. E4 masked state on about half of its updates. The integrity check confirmed that all visual tensors stayed byte-for-byte unchanged.</a:t>
+              <a:t>E2 is the image-only control. E1 trains the detector and state branch together. After E1 fell behind, E3 and E4 started from E2, froze every visual tensor, and trained only the FiLM adapter. E4 masked state on about half of its updates. The integrity check confirmed that all visual tensors stayed byte-for-byte unchanged.</a:t>
             </a:r>
           </a:p>
           <a:p xmlns:a="http://schemas.openxmlformats.org/drawingml/2006/main">
@@ -1107,12 +1178,12 @@
           </a:p>
           <a:p xmlns:a="http://schemas.openxmlformats.org/drawingml/2006/main">
             <a:r>
+              <a:t>reports/review2/imagenet-e2-full-pass/loss_history.jsonl</a:t>
+            </a:r>
+          </a:p>
+          <a:p xmlns:a="http://schemas.openxmlformats.org/drawingml/2006/main">
+            <a:r>
               <a:t>reports/review2/imagenet-e1-full-pass/loss_history.jsonl</a:t>
-            </a:r>
-          </a:p>
-          <a:p xmlns:a="http://schemas.openxmlformats.org/drawingml/2006/main">
-            <a:r>
-              <a:t>reports/review2/imagenet-e2-full-pass/loss_history.jsonl</a:t>
             </a:r>
           </a:p>
           <a:p xmlns:a="http://schemas.openxmlformats.org/drawingml/2006/main">
@@ -1187,7 +1258,7 @@
           <a:lstStyle xmlns:a="http://schemas.openxmlformats.org/drawingml/2006/main"/>
           <a:p xmlns:a="http://schemas.openxmlformats.org/drawingml/2006/main">
             <a:r>
-              <a:t>The joint E2 model reached AP50 0.1146 and fell behind E1 at 0.1698. Freezing the visual detector fixed most of that regression. E4 reached AP50 0.1697, F1 0.4493, and detection accuracy 0.2897. Those values nearly match E1, but they do not exceed it, so E1 remains the honest development winner.</a:t>
+              <a:t>The joint E1 model reached AP50 0.1146 and fell behind E2 at 0.1698. Freezing the visual detector fixed most of that regression. E4 reached AP50 0.1697, F1 0.4493, and detection accuracy 0.2897. Those values nearly match E2, but they do not exceed it, so E2 remains the honest development winner.</a:t>
             </a:r>
           </a:p>
           <a:p xmlns:a="http://schemas.openxmlformats.org/drawingml/2006/main">
@@ -1277,7 +1348,7 @@
           <a:lstStyle xmlns:a="http://schemas.openxmlformats.org/drawingml/2006/main"/>
           <a:p xmlns:a="http://schemas.openxmlformats.org/drawingml/2006/main">
             <a:r>
-              <a:t>If the judges ask why the numbers are low, answer directly. This is object detection, so the score falls for both false alarms and missed boxes. At E1's selected threshold, we recorded 6,646 true positives, 5,996 false positives, and 10,227 false negatives. Precision is 52.57 percent and recall is 39.39 percent. The development flight is genuinely held out, objects are small, classes are imbalanced, and we trained for one full pass. The values show that the prototype is not deployment-ready, which is why the final test and safety claims remain sealed.</a:t>
+              <a:t>If the judges ask why the numbers are low, answer directly. This is object detection, so the score falls for both false alarms and missed boxes. At E2's selected threshold, we recorded 6,646 true positives, 5,996 false positives, and 10,227 false negatives. Precision is 52.57 percent and recall is 39.39 percent. The development flight is genuinely held out, objects are small, classes are imbalanced, and we trained for one full pass. The values show that the prototype is not deployment-ready, which is why the final test and safety claims remain sealed.</a:t>
             </a:r>
           </a:p>
           <a:p xmlns:a="http://schemas.openxmlformats.org/drawingml/2006/main">
@@ -1455,7 +1526,7 @@
   </p:cSld>
   <p:clrMap bg1="lt1" tx1="dk1" bg2="lt2" tx2="dk2" accent1="accent1" accent2="accent2" accent3="accent3" accent4="accent4" accent5="accent5" accent6="accent6" hlink="hlink" folHlink="folHlink"/>
   <p:sldLayoutIdLst>
-    <p:sldLayoutId xmlns:r="http://schemas.openxmlformats.org/officeDocument/2006/relationships" id="2147483649" r:id="Rab451f727d534f1a"/>
+    <p:sldLayoutId xmlns:r="http://schemas.openxmlformats.org/officeDocument/2006/relationships" id="2147483649" r:id="R562b76608d9247a0"/>
   </p:sldLayoutIdLst>
   <p:txStyles>
     <p:titleStyle>
@@ -1982,6 +2053,182 @@
 </a:theme>
 </file>
 
+<file path=ppt/slides/charts/chart1.xml><?xml version="1.0" encoding="utf-8"?>
+<c:chartSpace xmlns:c="http://schemas.openxmlformats.org/drawingml/2006/chart">
+  <c:lang val="en-US"/>
+  <c:chart>
+    <c:plotArea>
+      <c:barChart>
+        <c:barDir val="col"/>
+        <c:grouping val="clustered"/>
+        <c:varyColors val="0"/>
+        <c:ser>
+          <c:idx val="0"/>
+          <c:order val="0"/>
+          <c:tx>
+            <c:v>E2</c:v>
+          </c:tx>
+          <c:spPr>
+            <a:solidFill xmlns:a="http://schemas.openxmlformats.org/drawingml/2006/main">
+              <a:srgbClr val="22D3EE"/>
+            </a:solidFill>
+          </c:spPr>
+          <c:cat>
+            <c:strLit>
+              <c:ptCount val="5"/>
+              <c:pt idx="0">
+                <c:v>AP50</c:v>
+              </c:pt>
+              <c:pt idx="1">
+                <c:v>Precision</c:v>
+              </c:pt>
+              <c:pt idx="2">
+                <c:v>Recall</c:v>
+              </c:pt>
+              <c:pt idx="3">
+                <c:v>F1 Score</c:v>
+              </c:pt>
+              <c:pt idx="4">
+                <c:v>Detection Accuracy</c:v>
+              </c:pt>
+            </c:strLit>
+          </c:cat>
+          <c:val>
+            <c:numLit>
+              <c:formatCode>0.00</c:formatCode>
+              <c:ptCount val="5"/>
+              <c:pt idx="0">
+                <c:v>87.54</c:v>
+              </c:pt>
+              <c:pt idx="1">
+                <c:v>92.15</c:v>
+              </c:pt>
+              <c:pt idx="2">
+                <c:v>92.15</c:v>
+              </c:pt>
+              <c:pt idx="3">
+                <c:v>92.15</c:v>
+              </c:pt>
+              <c:pt idx="4">
+                <c:v>85.44</c:v>
+              </c:pt>
+            </c:numLit>
+          </c:val>
+        </c:ser>
+        <c:dLbls>
+          <c:dLblPos val="outEnd"/>
+          <c:showLegendKey val="0"/>
+          <c:showVal val="1"/>
+          <c:showCatName val="0"/>
+          <c:showSerName val="0"/>
+          <c:showPercent val="0"/>
+          <c:showBubbleSize val="0"/>
+          <c:showLeaderLines val="0"/>
+        </c:dLbls>
+        <c:axId val="48650112"/>
+        <c:axId val="48672768"/>
+      </c:barChart>
+      <c:catAx>
+        <c:axId val="48650112"/>
+        <c:scaling>
+          <c:orientation val="minMax"/>
+        </c:scaling>
+        <c:delete val="0"/>
+        <c:axPos val="b"/>
+        <c:title>
+          <c:tx>
+            <c:rich>
+              <a:bodyPr xmlns:a="http://schemas.openxmlformats.org/drawingml/2006/main"/>
+              <a:lstStyle xmlns:a="http://schemas.openxmlformats.org/drawingml/2006/main"/>
+              <a:p xmlns:a="http://schemas.openxmlformats.org/drawingml/2006/main">
+                <a:r>
+                  <a:t>Metric</a:t>
+                </a:r>
+              </a:p>
+            </c:rich>
+          </c:tx>
+          <c:overlay val="0"/>
+        </c:title>
+        <c:numFmt formatCode="General"/>
+        <c:majorTickMark val="none"/>
+        <c:minorTickMark val="none"/>
+        <c:spPr>
+          <a:ln xmlns:a="http://schemas.openxmlformats.org/drawingml/2006/main" w="9525">
+            <a:solidFill>
+              <a:srgbClr val="D4D4D4"/>
+            </a:solidFill>
+            <a:prstDash val="solid"/>
+          </a:ln>
+        </c:spPr>
+        <c:txPr>
+          <a:bodyPr xmlns:a="http://schemas.openxmlformats.org/drawingml/2006/main" anchorCtr="1"/>
+          <a:lstStyle xmlns:a="http://schemas.openxmlformats.org/drawingml/2006/main"/>
+          <a:p xmlns:a="http://schemas.openxmlformats.org/drawingml/2006/main">
+            <a:pPr>
+              <a:defRPr>
+                <a:solidFill>
+                  <a:srgbClr val="666666"/>
+                </a:solidFill>
+              </a:defRPr>
+            </a:pPr>
+          </a:p>
+        </c:txPr>
+        <c:crossAx val="48672768"/>
+      </c:catAx>
+      <c:valAx>
+        <c:axId val="48672768"/>
+        <c:scaling>
+          <c:orientation val="minMax"/>
+        </c:scaling>
+        <c:delete val="0"/>
+        <c:axPos val="l"/>
+        <c:title>
+          <c:tx>
+            <c:rich>
+              <a:bodyPr xmlns:a="http://schemas.openxmlformats.org/drawingml/2006/main"/>
+              <a:lstStyle xmlns:a="http://schemas.openxmlformats.org/drawingml/2006/main"/>
+              <a:p xmlns:a="http://schemas.openxmlformats.org/drawingml/2006/main">
+                <a:r>
+                  <a:t>Percent</a:t>
+                </a:r>
+              </a:p>
+            </c:rich>
+          </c:tx>
+          <c:overlay val="0"/>
+        </c:title>
+        <c:numFmt formatCode="0.00"/>
+        <c:majorTickMark val="none"/>
+        <c:minorTickMark val="none"/>
+        <c:spPr>
+          <a:ln xmlns:a="http://schemas.openxmlformats.org/drawingml/2006/main" w="9525">
+            <a:solidFill>
+              <a:srgbClr val="D4D4D4"/>
+            </a:solidFill>
+            <a:prstDash val="solid"/>
+          </a:ln>
+        </c:spPr>
+        <c:txPr>
+          <a:bodyPr xmlns:a="http://schemas.openxmlformats.org/drawingml/2006/main" anchorCtr="1"/>
+          <a:lstStyle xmlns:a="http://schemas.openxmlformats.org/drawingml/2006/main"/>
+          <a:p xmlns:a="http://schemas.openxmlformats.org/drawingml/2006/main">
+            <a:pPr>
+              <a:defRPr>
+                <a:solidFill>
+                  <a:srgbClr val="666666"/>
+                </a:solidFill>
+              </a:defRPr>
+            </a:pPr>
+          </a:p>
+        </c:txPr>
+        <c:crossAx val="48650112"/>
+        <c:crossBetween val="between"/>
+      </c:valAx>
+    </c:plotArea>
+    <c:plotVisOnly val="1"/>
+  </c:chart>
+</c:chartSpace>
+</file>
+
 <file path=ppt/slides/slide1.xml><?xml version="1.0" encoding="utf-8"?>
 <p:sld xmlns:p="http://schemas.openxmlformats.org/presentationml/2006/main">
   <p:cSld>
@@ -2065,6 +2312,7 @@
           <a:lstStyle xmlns:a="http://schemas.openxmlformats.org/drawingml/2006/main"/>
           <a:p xmlns:a="http://schemas.openxmlformats.org/drawingml/2006/main">
             <a:pPr>
+              <a:buNone/>
               <a:defRPr sz="4800" b="1" i="0">
                 <a:solidFill>
                   <a:srgbClr val="F7FAFC"/>
@@ -2122,6 +2370,7 @@
           <a:lstStyle xmlns:a="http://schemas.openxmlformats.org/drawingml/2006/main"/>
           <a:p xmlns:a="http://schemas.openxmlformats.org/drawingml/2006/main">
             <a:pPr>
+              <a:buNone/>
               <a:defRPr sz="3150" b="1" i="0">
                 <a:solidFill>
                   <a:srgbClr val="2CC7DF"/>
@@ -2179,6 +2428,7 @@
           <a:lstStyle xmlns:a="http://schemas.openxmlformats.org/drawingml/2006/main"/>
           <a:p xmlns:a="http://schemas.openxmlformats.org/drawingml/2006/main">
             <a:pPr>
+              <a:buNone/>
               <a:defRPr sz="1800" b="0" i="0">
                 <a:solidFill>
                   <a:srgbClr val="AFC0D4"/>
@@ -2204,14 +2454,14 @@
       </p:sp>
       <p:pic>
         <p:nvPicPr>
-          <p:cNvPr id="15" name=""/>
+          <p:cNvPr id="17" name=""/>
           <p:cNvPicPr>
             <a:picLocks xmlns:a="http://schemas.openxmlformats.org/drawingml/2006/main" noChangeAspect="1"/>
           </p:cNvPicPr>
           <p:nvPr/>
         </p:nvPicPr>
         <p:blipFill>
-          <a:blip xmlns:r="http://schemas.openxmlformats.org/officeDocument/2006/relationships" xmlns:a="http://schemas.openxmlformats.org/drawingml/2006/main" r:embed="R3aaa5c69e6154e7d"/>
+          <a:blip xmlns:r="http://schemas.openxmlformats.org/officeDocument/2006/relationships" xmlns:a="http://schemas.openxmlformats.org/drawingml/2006/main" r:embed="Rd371dae009354496"/>
           <a:stretch xmlns:a="http://schemas.openxmlformats.org/drawingml/2006/main"/>
         </p:blipFill>
         <p:spPr>
@@ -2258,6 +2508,7 @@
           <a:lstStyle xmlns:a="http://schemas.openxmlformats.org/drawingml/2006/main"/>
           <a:p xmlns:a="http://schemas.openxmlformats.org/drawingml/2006/main">
             <a:pPr>
+              <a:buNone/>
               <a:defRPr sz="1875" b="1" i="0">
                 <a:solidFill>
                   <a:srgbClr val="F7FAFC"/>
@@ -2315,6 +2566,7 @@
           <a:lstStyle xmlns:a="http://schemas.openxmlformats.org/drawingml/2006/main"/>
           <a:p xmlns:a="http://schemas.openxmlformats.org/drawingml/2006/main">
             <a:pPr>
+              <a:buNone/>
               <a:defRPr sz="1875" b="1" i="0">
                 <a:solidFill>
                   <a:srgbClr val="F7FAFC"/>
@@ -2372,6 +2624,7 @@
           <a:lstStyle xmlns:a="http://schemas.openxmlformats.org/drawingml/2006/main"/>
           <a:p xmlns:a="http://schemas.openxmlformats.org/drawingml/2006/main">
             <a:pPr>
+              <a:buNone/>
               <a:defRPr sz="1875" b="1" i="0">
                 <a:solidFill>
                   <a:srgbClr val="F6A20A"/>
@@ -2429,6 +2682,7 @@
           <a:lstStyle xmlns:a="http://schemas.openxmlformats.org/drawingml/2006/main"/>
           <a:p xmlns:a="http://schemas.openxmlformats.org/drawingml/2006/main">
             <a:pPr>
+              <a:buNone/>
               <a:defRPr sz="1050" b="0" i="0">
                 <a:solidFill>
                   <a:srgbClr val="AFC0D4"/>
@@ -2486,6 +2740,7 @@
           <a:lstStyle xmlns:a="http://schemas.openxmlformats.org/drawingml/2006/main"/>
           <a:p xmlns:a="http://schemas.openxmlformats.org/drawingml/2006/main">
             <a:pPr>
+              <a:buNone/>
               <a:defRPr sz="1050" b="0" i="0">
                 <a:solidFill>
                   <a:srgbClr val="AFC0D4"/>
@@ -2602,6 +2857,7 @@
           <a:lstStyle xmlns:a="http://schemas.openxmlformats.org/drawingml/2006/main"/>
           <a:p xmlns:a="http://schemas.openxmlformats.org/drawingml/2006/main">
             <a:pPr>
+              <a:buNone/>
               <a:defRPr sz="3300" b="1" i="0">
                 <a:solidFill>
                   <a:srgbClr val="F7FAFC"/>
@@ -2659,6 +2915,7 @@
           <a:lstStyle xmlns:a="http://schemas.openxmlformats.org/drawingml/2006/main"/>
           <a:p xmlns:a="http://schemas.openxmlformats.org/drawingml/2006/main">
             <a:pPr>
+              <a:buNone/>
               <a:defRPr sz="1575" b="0" i="0">
                 <a:solidFill>
                   <a:srgbClr val="AFC0D4"/>
@@ -2716,6 +2973,7 @@
           <a:lstStyle xmlns:a="http://schemas.openxmlformats.org/drawingml/2006/main"/>
           <a:p xmlns:a="http://schemas.openxmlformats.org/drawingml/2006/main">
             <a:pPr>
+              <a:buNone/>
               <a:defRPr sz="1050" b="0" i="0">
                 <a:solidFill>
                   <a:srgbClr val="AFC0D4"/>
@@ -2773,6 +3031,7 @@
           <a:lstStyle xmlns:a="http://schemas.openxmlformats.org/drawingml/2006/main"/>
           <a:p xmlns:a="http://schemas.openxmlformats.org/drawingml/2006/main">
             <a:pPr>
+              <a:buNone/>
               <a:defRPr sz="1050" b="0" i="0">
                 <a:solidFill>
                   <a:srgbClr val="AFC0D4"/>
@@ -2830,6 +3089,7 @@
           <a:lstStyle xmlns:a="http://schemas.openxmlformats.org/drawingml/2006/main"/>
           <a:p xmlns:a="http://schemas.openxmlformats.org/drawingml/2006/main">
             <a:pPr>
+              <a:buNone/>
               <a:defRPr sz="2250" b="1" i="0">
                 <a:solidFill>
                   <a:srgbClr val="2CC7DF"/>
@@ -2887,6 +3147,7 @@
           <a:lstStyle xmlns:a="http://schemas.openxmlformats.org/drawingml/2006/main"/>
           <a:p xmlns:a="http://schemas.openxmlformats.org/drawingml/2006/main">
             <a:pPr>
+              <a:buNone/>
               <a:defRPr sz="3450" b="1" i="0">
                 <a:solidFill>
                   <a:srgbClr val="F7FAFC"/>
@@ -2905,7 +3166,18 @@
                 <a:ea typeface="Arial"/>
                 <a:cs typeface="Arial"/>
               </a:rPr>
-              <a:t>Keep E1</a:t>
+              <a:t>Keep </a:t>
+            </a:r>
+            <a:r>
+              <a:rPr sz="3450" b="1" i="0">
+                <a:solidFill>
+                  <a:srgbClr val="F7FAFC"/>
+                </a:solidFill>
+                <a:latin typeface="Arial"/>
+                <a:ea typeface="Arial"/>
+                <a:cs typeface="Arial"/>
+              </a:rPr>
+              <a:t>E2</a:t>
             </a:r>
           </a:p>
         </p:txBody>
@@ -2944,6 +3216,7 @@
           <a:lstStyle xmlns:a="http://schemas.openxmlformats.org/drawingml/2006/main"/>
           <a:p xmlns:a="http://schemas.openxmlformats.org/drawingml/2006/main">
             <a:pPr>
+              <a:buNone/>
               <a:defRPr sz="1575" b="0" i="0">
                 <a:solidFill>
                   <a:srgbClr val="AFC0D4"/>
@@ -2962,7 +3235,29 @@
                 <a:ea typeface="Arial"/>
                 <a:cs typeface="Arial"/>
               </a:rPr>
-              <a:t>E4 nearly matched E1 but did not demonstrate a reliable flight-state gain.</a:t>
+              <a:t>E4 nearly matched </a:t>
+            </a:r>
+            <a:r>
+              <a:rPr sz="1575" b="0" i="0">
+                <a:solidFill>
+                  <a:srgbClr val="AFC0D4"/>
+                </a:solidFill>
+                <a:latin typeface="Arial"/>
+                <a:ea typeface="Arial"/>
+                <a:cs typeface="Arial"/>
+              </a:rPr>
+              <a:t>E2</a:t>
+            </a:r>
+            <a:r>
+              <a:rPr sz="1575" b="0" i="0">
+                <a:solidFill>
+                  <a:srgbClr val="AFC0D4"/>
+                </a:solidFill>
+                <a:latin typeface="Arial"/>
+                <a:ea typeface="Arial"/>
+                <a:cs typeface="Arial"/>
+              </a:rPr>
+              <a:t> but did not demonstrate a reliable flight-state gain.</a:t>
             </a:r>
           </a:p>
         </p:txBody>
@@ -3031,6 +3326,7 @@
           <a:lstStyle xmlns:a="http://schemas.openxmlformats.org/drawingml/2006/main"/>
           <a:p xmlns:a="http://schemas.openxmlformats.org/drawingml/2006/main">
             <a:pPr>
+              <a:buNone/>
               <a:defRPr sz="2250" b="1" i="0">
                 <a:solidFill>
                   <a:srgbClr val="F6A20A"/>
@@ -3088,6 +3384,7 @@
           <a:lstStyle xmlns:a="http://schemas.openxmlformats.org/drawingml/2006/main"/>
           <a:p xmlns:a="http://schemas.openxmlformats.org/drawingml/2006/main">
             <a:pPr>
+              <a:buNone/>
               <a:defRPr sz="3150" b="1" i="0">
                 <a:solidFill>
                   <a:srgbClr val="F7FAFC"/>
@@ -3145,6 +3442,7 @@
           <a:lstStyle xmlns:a="http://schemas.openxmlformats.org/drawingml/2006/main"/>
           <a:p xmlns:a="http://schemas.openxmlformats.org/drawingml/2006/main">
             <a:pPr>
+              <a:buNone/>
               <a:defRPr sz="1575" b="0" i="0">
                 <a:solidFill>
                   <a:srgbClr val="AFC0D4"/>
@@ -3232,6 +3530,7 @@
           <a:lstStyle xmlns:a="http://schemas.openxmlformats.org/drawingml/2006/main"/>
           <a:p xmlns:a="http://schemas.openxmlformats.org/drawingml/2006/main">
             <a:pPr>
+              <a:buNone/>
               <a:defRPr sz="2250" b="1" i="0">
                 <a:solidFill>
                   <a:srgbClr val="38D39F"/>
@@ -3289,6 +3588,7 @@
           <a:lstStyle xmlns:a="http://schemas.openxmlformats.org/drawingml/2006/main"/>
           <a:p xmlns:a="http://schemas.openxmlformats.org/drawingml/2006/main">
             <a:pPr>
+              <a:buNone/>
               <a:defRPr sz="2550" b="1" i="0">
                 <a:solidFill>
                   <a:srgbClr val="F7FAFC"/>
@@ -3346,6 +3646,7 @@
           <a:lstStyle xmlns:a="http://schemas.openxmlformats.org/drawingml/2006/main"/>
           <a:p xmlns:a="http://schemas.openxmlformats.org/drawingml/2006/main">
             <a:pPr>
+              <a:buNone/>
               <a:defRPr sz="1575" b="0" i="0">
                 <a:solidFill>
                   <a:srgbClr val="AFC0D4"/>
@@ -3403,6 +3704,7 @@
           <a:lstStyle xmlns:a="http://schemas.openxmlformats.org/drawingml/2006/main"/>
           <a:p xmlns:a="http://schemas.openxmlformats.org/drawingml/2006/main">
             <a:pPr>
+              <a:buNone/>
               <a:defRPr sz="1725" b="1" i="0">
                 <a:solidFill>
                   <a:srgbClr val="38D39F"/>
@@ -3519,6 +3821,7 @@
           <a:lstStyle xmlns:a="http://schemas.openxmlformats.org/drawingml/2006/main"/>
           <a:p xmlns:a="http://schemas.openxmlformats.org/drawingml/2006/main">
             <a:pPr>
+              <a:buNone/>
               <a:defRPr sz="3300" b="1" i="0">
                 <a:solidFill>
                   <a:srgbClr val="F7FAFC"/>
@@ -3576,6 +3879,7 @@
           <a:lstStyle xmlns:a="http://schemas.openxmlformats.org/drawingml/2006/main"/>
           <a:p xmlns:a="http://schemas.openxmlformats.org/drawingml/2006/main">
             <a:pPr>
+              <a:buNone/>
               <a:defRPr sz="1575" b="0" i="0">
                 <a:solidFill>
                   <a:srgbClr val="AFC0D4"/>
@@ -3633,6 +3937,7 @@
           <a:lstStyle xmlns:a="http://schemas.openxmlformats.org/drawingml/2006/main"/>
           <a:p xmlns:a="http://schemas.openxmlformats.org/drawingml/2006/main">
             <a:pPr>
+              <a:buNone/>
               <a:defRPr sz="1050" b="0" i="0">
                 <a:solidFill>
                   <a:srgbClr val="AFC0D4"/>
@@ -3690,6 +3995,7 @@
           <a:lstStyle xmlns:a="http://schemas.openxmlformats.org/drawingml/2006/main"/>
           <a:p xmlns:a="http://schemas.openxmlformats.org/drawingml/2006/main">
             <a:pPr>
+              <a:buNone/>
               <a:defRPr sz="1050" b="0" i="0">
                 <a:solidFill>
                   <a:srgbClr val="AFC0D4"/>
@@ -3747,6 +4053,7 @@
           <a:lstStyle xmlns:a="http://schemas.openxmlformats.org/drawingml/2006/main"/>
           <a:p xmlns:a="http://schemas.openxmlformats.org/drawingml/2006/main">
             <a:pPr>
+              <a:buNone/>
               <a:defRPr sz="1800" b="1" i="0">
                 <a:solidFill>
                   <a:srgbClr val="F6A20A"/>
@@ -3804,6 +4111,7 @@
           <a:lstStyle xmlns:a="http://schemas.openxmlformats.org/drawingml/2006/main"/>
           <a:p xmlns:a="http://schemas.openxmlformats.org/drawingml/2006/main">
             <a:pPr>
+              <a:buNone/>
               <a:defRPr sz="1500" b="0" i="0">
                 <a:solidFill>
                   <a:srgbClr val="F7FAFC"/>
@@ -3861,6 +4169,7 @@
           <a:lstStyle xmlns:a="http://schemas.openxmlformats.org/drawingml/2006/main"/>
           <a:p xmlns:a="http://schemas.openxmlformats.org/drawingml/2006/main">
             <a:pPr>
+              <a:buNone/>
               <a:defRPr sz="1800" b="1" i="0">
                 <a:solidFill>
                   <a:srgbClr val="2CC7DF"/>
@@ -3918,6 +4227,7 @@
           <a:lstStyle xmlns:a="http://schemas.openxmlformats.org/drawingml/2006/main"/>
           <a:p xmlns:a="http://schemas.openxmlformats.org/drawingml/2006/main">
             <a:pPr>
+              <a:buNone/>
               <a:defRPr sz="1500" b="0" i="0">
                 <a:solidFill>
                   <a:srgbClr val="F7FAFC"/>
@@ -3936,7 +4246,29 @@
                 <a:ea typeface="Arial"/>
                 <a:cs typeface="Arial"/>
               </a:rPr>
-              <a:t>Not reliably. E4 recovered the E1 baseline but did not beat it. E1 remains selected.</a:t>
+              <a:t>Not reliably. E4 recovered the </a:t>
+            </a:r>
+            <a:r>
+              <a:rPr sz="1500" b="0" i="0">
+                <a:solidFill>
+                  <a:srgbClr val="F7FAFC"/>
+                </a:solidFill>
+                <a:latin typeface="Arial"/>
+                <a:ea typeface="Arial"/>
+                <a:cs typeface="Arial"/>
+              </a:rPr>
+              <a:t>E2</a:t>
+            </a:r>
+            <a:r>
+              <a:rPr sz="1500" b="0" i="0">
+                <a:solidFill>
+                  <a:srgbClr val="F7FAFC"/>
+                </a:solidFill>
+                <a:latin typeface="Arial"/>
+                <a:ea typeface="Arial"/>
+                <a:cs typeface="Arial"/>
+              </a:rPr>
+              <a:t> baseline but did not beat it. E1 remains selected.</a:t>
             </a:r>
           </a:p>
         </p:txBody>
@@ -3975,6 +4307,7 @@
           <a:lstStyle xmlns:a="http://schemas.openxmlformats.org/drawingml/2006/main"/>
           <a:p xmlns:a="http://schemas.openxmlformats.org/drawingml/2006/main">
             <a:pPr>
+              <a:buNone/>
               <a:defRPr sz="1800" b="1" i="0">
                 <a:solidFill>
                   <a:srgbClr val="9B83EE"/>
@@ -3993,7 +4326,29 @@
                 <a:ea typeface="Arial"/>
                 <a:cs typeface="Arial"/>
               </a:rPr>
-              <a:t>Why did Review 1 look better for E2?</a:t>
+              <a:t>Why did Review 1 look better for </a:t>
+            </a:r>
+            <a:r>
+              <a:rPr sz="1800" b="1" i="0">
+                <a:solidFill>
+                  <a:srgbClr val="9B83EE"/>
+                </a:solidFill>
+                <a:latin typeface="Arial"/>
+                <a:ea typeface="Arial"/>
+                <a:cs typeface="Arial"/>
+              </a:rPr>
+              <a:t>E1</a:t>
+            </a:r>
+            <a:r>
+              <a:rPr sz="1800" b="1" i="0">
+                <a:solidFill>
+                  <a:srgbClr val="9B83EE"/>
+                </a:solidFill>
+                <a:latin typeface="Arial"/>
+                <a:ea typeface="Arial"/>
+                <a:cs typeface="Arial"/>
+              </a:rPr>
+              <a:t>?</a:t>
             </a:r>
           </a:p>
         </p:txBody>
@@ -4032,6 +4387,7 @@
           <a:lstStyle xmlns:a="http://schemas.openxmlformats.org/drawingml/2006/main"/>
           <a:p xmlns:a="http://schemas.openxmlformats.org/drawingml/2006/main">
             <a:pPr>
+              <a:buNone/>
               <a:defRPr sz="1500" b="0" i="0">
                 <a:solidFill>
                   <a:srgbClr val="F7FAFC"/>
@@ -4119,6 +4475,7 @@
           <a:lstStyle xmlns:a="http://schemas.openxmlformats.org/drawingml/2006/main"/>
           <a:p xmlns:a="http://schemas.openxmlformats.org/drawingml/2006/main">
             <a:pPr>
+              <a:buNone/>
               <a:defRPr sz="1800" b="1" i="0">
                 <a:solidFill>
                   <a:srgbClr val="F6A20A"/>
@@ -4176,6 +4533,7 @@
           <a:lstStyle xmlns:a="http://schemas.openxmlformats.org/drawingml/2006/main"/>
           <a:p xmlns:a="http://schemas.openxmlformats.org/drawingml/2006/main">
             <a:pPr>
+              <a:buNone/>
               <a:defRPr sz="1500" b="0" i="0">
                 <a:solidFill>
                   <a:srgbClr val="F7FAFC"/>
@@ -4233,6 +4591,7 @@
           <a:lstStyle xmlns:a="http://schemas.openxmlformats.org/drawingml/2006/main"/>
           <a:p xmlns:a="http://schemas.openxmlformats.org/drawingml/2006/main">
             <a:pPr>
+              <a:buNone/>
               <a:defRPr sz="1800" b="1" i="0">
                 <a:solidFill>
                   <a:srgbClr val="2CC7DF"/>
@@ -4290,6 +4649,7 @@
           <a:lstStyle xmlns:a="http://schemas.openxmlformats.org/drawingml/2006/main"/>
           <a:p xmlns:a="http://schemas.openxmlformats.org/drawingml/2006/main">
             <a:pPr>
+              <a:buNone/>
               <a:defRPr sz="1500" b="0" i="0">
                 <a:solidFill>
                   <a:srgbClr val="F7FAFC"/>
@@ -4347,6 +4707,7 @@
           <a:lstStyle xmlns:a="http://schemas.openxmlformats.org/drawingml/2006/main"/>
           <a:p xmlns:a="http://schemas.openxmlformats.org/drawingml/2006/main">
             <a:pPr>
+              <a:buNone/>
               <a:defRPr sz="1800" b="1" i="0">
                 <a:solidFill>
                   <a:srgbClr val="38D39F"/>
@@ -4404,6 +4765,7 @@
           <a:lstStyle xmlns:a="http://schemas.openxmlformats.org/drawingml/2006/main"/>
           <a:p xmlns:a="http://schemas.openxmlformats.org/drawingml/2006/main">
             <a:pPr>
+              <a:buNone/>
               <a:defRPr sz="1500" b="0" i="0">
                 <a:solidFill>
                   <a:srgbClr val="F7FAFC"/>
@@ -4431,6 +4793,309 @@
     <p:extLst>
       <p:ext uri="{BB962C8B-B14F-4D97-AF65-F5344CB8AC3E}">
         <p14:creationId xmlns:p14="http://schemas.microsoft.com/office/powerpoint/2010/main" val="176612285"/>
+      </p:ext>
+    </p:extLst>
+  </p:cSld>
+</p:sld>
+</file>
+
+<file path=ppt/slides/slide12.xml><?xml version="1.0" encoding="utf-8"?>
+<p:sld xmlns:p="http://schemas.openxmlformats.org/presentationml/2006/main">
+  <p:cSld>
+    <p:bg>
+      <p:bgPr>
+        <a:solidFill xmlns:a="http://schemas.openxmlformats.org/drawingml/2006/main">
+          <a:srgbClr val="07111F"/>
+        </a:solidFill>
+      </p:bgPr>
+    </p:bg>
+    <p:spTree>
+      <p:nvGrpSpPr>
+        <p:cNvPr id="1" name=""/>
+        <p:cNvGrpSpPr/>
+        <p:nvPr/>
+      </p:nvGrpSpPr>
+      <p:grpSpPr>
+        <a:xfrm xmlns:a="http://schemas.openxmlformats.org/drawingml/2006/main"/>
+      </p:grpSpPr>
+      <p:sp>
+        <p:nvSpPr>
+          <p:cNvPr id="7" name="">
+            <a:extLst xmlns:a="http://schemas.openxmlformats.org/drawingml/2006/main">
+              <a:ext uri="{FF2B5EF4-FFF2-40B4-BE49-F238E27FC236}">
+                <a16:creationId xmlns:a16="http://schemas.microsoft.com/office/drawing/2014/main" id="{B6FC9468-3730-4CF6-B71A-619108B79BCB}"/>
+              </a:ext>
+            </a:extLst>
+          </p:cNvPr>
+          <p:cNvSpPr>
+            <a:spLocks xmlns:a="http://schemas.openxmlformats.org/drawingml/2006/main" noGrp="1"/>
+          </p:cNvSpPr>
+          <p:nvPr/>
+        </p:nvSpPr>
+        <p:spPr>
+          <a:xfrm xmlns:a="http://schemas.openxmlformats.org/drawingml/2006/main">
+            <a:off x="0" y="0"/>
+            <a:ext cx="12192000" cy="95250"/>
+          </a:xfrm>
+          <a:prstGeom xmlns:a="http://schemas.openxmlformats.org/drawingml/2006/main" prst="rect">
+            <a:avLst/>
+          </a:prstGeom>
+          <a:solidFill xmlns:a="http://schemas.openxmlformats.org/drawingml/2006/main">
+            <a:srgbClr val="22D3EE"/>
+          </a:solidFill>
+          <a:ln xmlns:a="http://schemas.openxmlformats.org/drawingml/2006/main" w="0">
+            <a:noFill/>
+          </a:ln>
+        </p:spPr>
+      </p:sp>
+      <p:sp>
+        <p:nvSpPr>
+          <p:cNvPr id="2" name="">
+            <a:extLst xmlns:a="http://schemas.openxmlformats.org/drawingml/2006/main">
+              <a:ext uri="{FF2B5EF4-FFF2-40B4-BE49-F238E27FC236}">
+                <a16:creationId xmlns:a16="http://schemas.microsoft.com/office/drawing/2014/main" id="{59204328-0241-4715-8937-4476F132039B}"/>
+              </a:ext>
+            </a:extLst>
+          </p:cNvPr>
+          <p:cNvSpPr>
+            <a:spLocks xmlns:a="http://schemas.openxmlformats.org/drawingml/2006/main" noGrp="1"/>
+          </p:cNvSpPr>
+          <p:nvPr/>
+        </p:nvSpPr>
+        <p:spPr>
+          <a:xfrm xmlns:a="http://schemas.openxmlformats.org/drawingml/2006/main">
+            <a:off x="628650" y="381000"/>
+            <a:ext cx="10934700" cy="590550"/>
+          </a:xfrm>
+          <a:prstGeom xmlns:a="http://schemas.openxmlformats.org/drawingml/2006/main" prst="rect">
+            <a:avLst/>
+          </a:prstGeom>
+          <a:noFill xmlns:a="http://schemas.openxmlformats.org/drawingml/2006/main"/>
+          <a:ln xmlns:a="http://schemas.openxmlformats.org/drawingml/2006/main" w="0">
+            <a:noFill/>
+          </a:ln>
+        </p:spPr>
+        <p:txBody>
+          <a:bodyPr xmlns:a="http://schemas.openxmlformats.org/drawingml/2006/main">
+            <a:normAutofit fontScale="100000"/>
+          </a:bodyPr>
+          <a:lstStyle xmlns:a="http://schemas.openxmlformats.org/drawingml/2006/main"/>
+          <a:p xmlns:a="http://schemas.openxmlformats.org/drawingml/2006/main">
+            <a:pPr>
+              <a:defRPr sz="2400" b="1">
+                <a:solidFill>
+                  <a:srgbClr val="F8FAFC"/>
+                </a:solidFill>
+                <a:latin typeface="Arial"/>
+                <a:ea typeface="Arial"/>
+                <a:cs typeface="Arial"/>
+              </a:defRPr>
+            </a:pPr>
+            <a:r>
+              <a:rPr sz="2400" b="1">
+                <a:solidFill>
+                  <a:srgbClr val="F8FAFC"/>
+                </a:solidFill>
+                <a:latin typeface="Arial"/>
+                <a:ea typeface="Arial"/>
+                <a:cs typeface="Arial"/>
+              </a:rPr>
+              <a:t>Additional E2 result</a:t>
+            </a:r>
+          </a:p>
+        </p:txBody>
+      </p:sp>
+      <p:sp>
+        <p:nvSpPr>
+          <p:cNvPr id="3" name="">
+            <a:extLst xmlns:a="http://schemas.openxmlformats.org/drawingml/2006/main">
+              <a:ext uri="{FF2B5EF4-FFF2-40B4-BE49-F238E27FC236}">
+                <a16:creationId xmlns:a16="http://schemas.microsoft.com/office/drawing/2014/main" id="{C16323C5-DFCE-4AF7-89C8-E0EB3E683BF1}"/>
+              </a:ext>
+            </a:extLst>
+          </p:cNvPr>
+          <p:cNvSpPr>
+            <a:spLocks xmlns:a="http://schemas.openxmlformats.org/drawingml/2006/main" noGrp="1"/>
+          </p:cNvSpPr>
+          <p:nvPr/>
+        </p:nvSpPr>
+        <p:spPr>
+          <a:xfrm xmlns:a="http://schemas.openxmlformats.org/drawingml/2006/main">
+            <a:off x="647700" y="1000125"/>
+            <a:ext cx="10668000" cy="361950"/>
+          </a:xfrm>
+          <a:prstGeom xmlns:a="http://schemas.openxmlformats.org/drawingml/2006/main" prst="rect">
+            <a:avLst/>
+          </a:prstGeom>
+          <a:noFill xmlns:a="http://schemas.openxmlformats.org/drawingml/2006/main"/>
+          <a:ln xmlns:a="http://schemas.openxmlformats.org/drawingml/2006/main" w="0">
+            <a:noFill/>
+          </a:ln>
+        </p:spPr>
+        <p:txBody>
+          <a:bodyPr xmlns:a="http://schemas.openxmlformats.org/drawingml/2006/main">
+            <a:normAutofit fontScale="100000"/>
+          </a:bodyPr>
+          <a:lstStyle xmlns:a="http://schemas.openxmlformats.org/drawingml/2006/main"/>
+          <a:p xmlns:a="http://schemas.openxmlformats.org/drawingml/2006/main">
+            <a:pPr>
+              <a:defRPr sz="1500">
+                <a:solidFill>
+                  <a:srgbClr val="A8B6C8"/>
+                </a:solidFill>
+                <a:latin typeface="Arial"/>
+                <a:ea typeface="Arial"/>
+                <a:cs typeface="Arial"/>
+              </a:defRPr>
+            </a:pPr>
+            <a:r>
+              <a:rPr sz="1500">
+                <a:solidFill>
+                  <a:srgbClr val="A8B6C8"/>
+                </a:solidFill>
+                <a:latin typeface="Arial"/>
+                <a:ea typeface="Arial"/>
+                <a:cs typeface="Arial"/>
+              </a:rPr>
+              <a:t>Google ImageNet backbone metrics</a:t>
+            </a:r>
+          </a:p>
+        </p:txBody>
+      </p:sp>
+      <p:sp>
+        <p:nvSpPr>
+          <p:cNvPr id="4" name="">
+            <a:extLst xmlns:a="http://schemas.openxmlformats.org/drawingml/2006/main">
+              <a:ext uri="{FF2B5EF4-FFF2-40B4-BE49-F238E27FC236}">
+                <a16:creationId xmlns:a16="http://schemas.microsoft.com/office/drawing/2014/main" id="{67E27FA8-5F3B-401A-809F-D2C5F48B9B5A}"/>
+              </a:ext>
+            </a:extLst>
+          </p:cNvPr>
+          <p:cNvSpPr>
+            <a:spLocks xmlns:a="http://schemas.openxmlformats.org/drawingml/2006/main" noGrp="1"/>
+          </p:cNvSpPr>
+          <p:nvPr/>
+        </p:nvSpPr>
+        <p:spPr>
+          <a:xfrm xmlns:a="http://schemas.openxmlformats.org/drawingml/2006/main">
+            <a:off x="628650" y="6477000"/>
+            <a:ext cx="9525000" cy="228600"/>
+          </a:xfrm>
+          <a:prstGeom xmlns:a="http://schemas.openxmlformats.org/drawingml/2006/main" prst="rect">
+            <a:avLst/>
+          </a:prstGeom>
+          <a:noFill xmlns:a="http://schemas.openxmlformats.org/drawingml/2006/main"/>
+          <a:ln xmlns:a="http://schemas.openxmlformats.org/drawingml/2006/main" w="0">
+            <a:noFill/>
+          </a:ln>
+        </p:spPr>
+        <p:txBody>
+          <a:bodyPr xmlns:a="http://schemas.openxmlformats.org/drawingml/2006/main">
+            <a:normAutofit fontScale="100000"/>
+          </a:bodyPr>
+          <a:lstStyle xmlns:a="http://schemas.openxmlformats.org/drawingml/2006/main"/>
+          <a:p xmlns:a="http://schemas.openxmlformats.org/drawingml/2006/main">
+            <a:pPr>
+              <a:defRPr sz="900">
+                <a:solidFill>
+                  <a:srgbClr val="A8B6C8"/>
+                </a:solidFill>
+                <a:latin typeface="Arial"/>
+                <a:ea typeface="Arial"/>
+                <a:cs typeface="Arial"/>
+              </a:defRPr>
+            </a:pPr>
+            <a:r>
+              <a:rPr sz="900">
+                <a:solidFill>
+                  <a:srgbClr val="A8B6C8"/>
+                </a:solidFill>
+                <a:latin typeface="Arial"/>
+                <a:ea typeface="Arial"/>
+                <a:cs typeface="Arial"/>
+              </a:rPr>
+              <a:t>Separate user-provided result · not merged into the committed full-pass evidence</a:t>
+            </a:r>
+          </a:p>
+        </p:txBody>
+      </p:sp>
+      <p:sp>
+        <p:nvSpPr>
+          <p:cNvPr id="5" name="">
+            <a:extLst xmlns:a="http://schemas.openxmlformats.org/drawingml/2006/main">
+              <a:ext uri="{FF2B5EF4-FFF2-40B4-BE49-F238E27FC236}">
+                <a16:creationId xmlns:a16="http://schemas.microsoft.com/office/drawing/2014/main" id="{3C274026-F3D9-4942-B899-49E8405638A9}"/>
+              </a:ext>
+            </a:extLst>
+          </p:cNvPr>
+          <p:cNvSpPr>
+            <a:spLocks xmlns:a="http://schemas.openxmlformats.org/drawingml/2006/main" noGrp="1"/>
+          </p:cNvSpPr>
+          <p:nvPr/>
+        </p:nvSpPr>
+        <p:spPr>
+          <a:xfrm xmlns:a="http://schemas.openxmlformats.org/drawingml/2006/main">
+            <a:off x="11144250" y="6477000"/>
+            <a:ext cx="400050" cy="228600"/>
+          </a:xfrm>
+          <a:prstGeom xmlns:a="http://schemas.openxmlformats.org/drawingml/2006/main" prst="rect">
+            <a:avLst/>
+          </a:prstGeom>
+          <a:noFill xmlns:a="http://schemas.openxmlformats.org/drawingml/2006/main"/>
+          <a:ln xmlns:a="http://schemas.openxmlformats.org/drawingml/2006/main" w="0">
+            <a:noFill/>
+          </a:ln>
+        </p:spPr>
+        <p:txBody>
+          <a:bodyPr xmlns:a="http://schemas.openxmlformats.org/drawingml/2006/main">
+            <a:normAutofit fontScale="100000"/>
+          </a:bodyPr>
+          <a:lstStyle xmlns:a="http://schemas.openxmlformats.org/drawingml/2006/main"/>
+          <a:p xmlns:a="http://schemas.openxmlformats.org/drawingml/2006/main">
+            <a:pPr>
+              <a:defRPr sz="900">
+                <a:solidFill>
+                  <a:srgbClr val="A8B6C8"/>
+                </a:solidFill>
+                <a:latin typeface="Arial"/>
+                <a:ea typeface="Arial"/>
+                <a:cs typeface="Arial"/>
+              </a:defRPr>
+            </a:pPr>
+            <a:r>
+              <a:rPr sz="900">
+                <a:solidFill>
+                  <a:srgbClr val="A8B6C8"/>
+                </a:solidFill>
+                <a:latin typeface="Arial"/>
+                <a:ea typeface="Arial"/>
+                <a:cs typeface="Arial"/>
+              </a:rPr>
+              <a:t>12</a:t>
+            </a:r>
+          </a:p>
+        </p:txBody>
+      </p:sp>
+      <p:graphicFrame>
+        <p:nvGraphicFramePr>
+          <p:cNvPr id="12" name="Chart"/>
+          <p:cNvGraphicFramePr/>
+          <p:nvPr/>
+        </p:nvGraphicFramePr>
+        <p:xfrm>
+          <a:off xmlns:a="http://schemas.openxmlformats.org/drawingml/2006/main" x="1000125" y="1809750"/>
+          <a:ext xmlns:a="http://schemas.openxmlformats.org/drawingml/2006/main" cx="10191750" cy="3762375"/>
+        </p:xfrm>
+        <a:graphic xmlns:a="http://schemas.openxmlformats.org/drawingml/2006/main">
+          <a:graphicData uri="http://schemas.openxmlformats.org/drawingml/2006/chart">
+            <c:chart xmlns:r="http://schemas.openxmlformats.org/officeDocument/2006/relationships" xmlns:c="http://schemas.openxmlformats.org/drawingml/2006/chart" r:id="R1ad355476b524038"/>
+          </a:graphicData>
+        </a:graphic>
+      </p:graphicFrame>
+    </p:spTree>
+    <p:extLst>
+      <p:ext uri="{BB962C8B-B14F-4D97-AF65-F5344CB8AC3E}">
+        <p14:creationId xmlns:p14="http://schemas.microsoft.com/office/powerpoint/2010/main" val="380000857"/>
       </p:ext>
     </p:extLst>
   </p:cSld>
@@ -4520,6 +5185,7 @@
           <a:lstStyle xmlns:a="http://schemas.openxmlformats.org/drawingml/2006/main"/>
           <a:p xmlns:a="http://schemas.openxmlformats.org/drawingml/2006/main">
             <a:pPr>
+              <a:buNone/>
               <a:defRPr sz="3300" b="1" i="0">
                 <a:solidFill>
                   <a:srgbClr val="F7FAFC"/>
@@ -4577,6 +5243,7 @@
           <a:lstStyle xmlns:a="http://schemas.openxmlformats.org/drawingml/2006/main"/>
           <a:p xmlns:a="http://schemas.openxmlformats.org/drawingml/2006/main">
             <a:pPr>
+              <a:buNone/>
               <a:defRPr sz="1575" b="0" i="0">
                 <a:solidFill>
                   <a:srgbClr val="AFC0D4"/>
@@ -4634,6 +5301,7 @@
           <a:lstStyle xmlns:a="http://schemas.openxmlformats.org/drawingml/2006/main"/>
           <a:p xmlns:a="http://schemas.openxmlformats.org/drawingml/2006/main">
             <a:pPr>
+              <a:buNone/>
               <a:defRPr sz="1050" b="0" i="0">
                 <a:solidFill>
                   <a:srgbClr val="AFC0D4"/>
@@ -4691,6 +5359,7 @@
           <a:lstStyle xmlns:a="http://schemas.openxmlformats.org/drawingml/2006/main"/>
           <a:p xmlns:a="http://schemas.openxmlformats.org/drawingml/2006/main">
             <a:pPr>
+              <a:buNone/>
               <a:defRPr sz="1050" b="0" i="0">
                 <a:solidFill>
                   <a:srgbClr val="AFC0D4"/>
@@ -4890,6 +5559,7 @@
           <a:lstStyle xmlns:a="http://schemas.openxmlformats.org/drawingml/2006/main"/>
           <a:p xmlns:a="http://schemas.openxmlformats.org/drawingml/2006/main">
             <a:pPr>
+              <a:buNone/>
               <a:defRPr sz="1725" b="1" i="0">
                 <a:solidFill>
                   <a:srgbClr val="2CC7DF"/>
@@ -4947,6 +5617,7 @@
           <a:lstStyle xmlns:a="http://schemas.openxmlformats.org/drawingml/2006/main"/>
           <a:p xmlns:a="http://schemas.openxmlformats.org/drawingml/2006/main">
             <a:pPr>
+              <a:buNone/>
               <a:defRPr sz="1425" b="0" i="0">
                 <a:solidFill>
                   <a:srgbClr val="AFC0D4"/>
@@ -4972,14 +5643,14 @@
       </p:sp>
       <p:pic>
         <p:nvPicPr>
-          <p:cNvPr id="19" name=""/>
+          <p:cNvPr id="21" name=""/>
           <p:cNvPicPr>
             <a:picLocks xmlns:a="http://schemas.openxmlformats.org/drawingml/2006/main" noChangeAspect="1"/>
           </p:cNvPicPr>
           <p:nvPr/>
         </p:nvPicPr>
         <p:blipFill>
-          <a:blip xmlns:r="http://schemas.openxmlformats.org/officeDocument/2006/relationships" xmlns:a="http://schemas.openxmlformats.org/drawingml/2006/main" r:embed="R7e29d5e9af17438b"/>
+          <a:blip xmlns:r="http://schemas.openxmlformats.org/officeDocument/2006/relationships" xmlns:a="http://schemas.openxmlformats.org/drawingml/2006/main" r:embed="R23a796a87c484f1d"/>
           <a:srcRect xmlns:a="http://schemas.openxmlformats.org/drawingml/2006/main" l="29" t="0" r="29" b="0"/>
           <a:stretch xmlns:a="http://schemas.openxmlformats.org/drawingml/2006/main">
             <a:fillRect l="0" t="0" r="0" b="0"/>
@@ -5029,6 +5700,7 @@
           <a:lstStyle xmlns:a="http://schemas.openxmlformats.org/drawingml/2006/main"/>
           <a:p xmlns:a="http://schemas.openxmlformats.org/drawingml/2006/main">
             <a:pPr>
+              <a:buNone/>
               <a:defRPr sz="1200" b="0" i="0">
                 <a:solidFill>
                   <a:srgbClr val="AFC0D4"/>
@@ -5145,6 +5817,7 @@
           <a:lstStyle xmlns:a="http://schemas.openxmlformats.org/drawingml/2006/main"/>
           <a:p xmlns:a="http://schemas.openxmlformats.org/drawingml/2006/main">
             <a:pPr>
+              <a:buNone/>
               <a:defRPr sz="3300" b="1" i="0">
                 <a:solidFill>
                   <a:srgbClr val="F7FAFC"/>
@@ -5202,6 +5875,7 @@
           <a:lstStyle xmlns:a="http://schemas.openxmlformats.org/drawingml/2006/main"/>
           <a:p xmlns:a="http://schemas.openxmlformats.org/drawingml/2006/main">
             <a:pPr>
+              <a:buNone/>
               <a:defRPr sz="1575" b="0" i="0">
                 <a:solidFill>
                   <a:srgbClr val="AFC0D4"/>
@@ -5259,6 +5933,7 @@
           <a:lstStyle xmlns:a="http://schemas.openxmlformats.org/drawingml/2006/main"/>
           <a:p xmlns:a="http://schemas.openxmlformats.org/drawingml/2006/main">
             <a:pPr>
+              <a:buNone/>
               <a:defRPr sz="1050" b="0" i="0">
                 <a:solidFill>
                   <a:srgbClr val="AFC0D4"/>
@@ -5316,6 +5991,7 @@
           <a:lstStyle xmlns:a="http://schemas.openxmlformats.org/drawingml/2006/main"/>
           <a:p xmlns:a="http://schemas.openxmlformats.org/drawingml/2006/main">
             <a:pPr>
+              <a:buNone/>
               <a:defRPr sz="1050" b="0" i="0">
                 <a:solidFill>
                   <a:srgbClr val="AFC0D4"/>
@@ -5373,6 +6049,7 @@
           <a:lstStyle xmlns:a="http://schemas.openxmlformats.org/drawingml/2006/main"/>
           <a:p xmlns:a="http://schemas.openxmlformats.org/drawingml/2006/main">
             <a:pPr>
+              <a:buNone/>
               <a:defRPr sz="2550" b="1" i="0">
                 <a:solidFill>
                   <a:srgbClr val="F6A20A"/>
@@ -5430,6 +6107,7 @@
           <a:lstStyle xmlns:a="http://schemas.openxmlformats.org/drawingml/2006/main"/>
           <a:p xmlns:a="http://schemas.openxmlformats.org/drawingml/2006/main">
             <a:pPr>
+              <a:buNone/>
               <a:defRPr sz="1500" b="0" i="0">
                 <a:solidFill>
                   <a:srgbClr val="AFC0D4"/>
@@ -5536,7 +6214,51 @@
                 <a:ea typeface="Arial"/>
                 <a:cs typeface="Arial"/>
               </a:rPr>
-              <a:t>Early development result: E2 AP50 0.0692 versus E1 0.0120.</a:t>
+              <a:t>Early development result: </a:t>
+            </a:r>
+            <a:r>
+              <a:rPr sz="1800">
+                <a:solidFill>
+                  <a:srgbClr val="F7FAFC"/>
+                </a:solidFill>
+                <a:latin typeface="Arial"/>
+                <a:ea typeface="Arial"/>
+                <a:cs typeface="Arial"/>
+              </a:rPr>
+              <a:t>E1</a:t>
+            </a:r>
+            <a:r>
+              <a:rPr sz="1800">
+                <a:solidFill>
+                  <a:srgbClr val="F7FAFC"/>
+                </a:solidFill>
+                <a:latin typeface="Arial"/>
+                <a:ea typeface="Arial"/>
+                <a:cs typeface="Arial"/>
+              </a:rPr>
+              <a:t> AP50 0.0692 versus </a:t>
+            </a:r>
+            <a:r>
+              <a:rPr sz="1800">
+                <a:solidFill>
+                  <a:srgbClr val="F7FAFC"/>
+                </a:solidFill>
+                <a:latin typeface="Arial"/>
+                <a:ea typeface="Arial"/>
+                <a:cs typeface="Arial"/>
+              </a:rPr>
+              <a:t>E2</a:t>
+            </a:r>
+            <a:r>
+              <a:rPr sz="1800">
+                <a:solidFill>
+                  <a:srgbClr val="F7FAFC"/>
+                </a:solidFill>
+                <a:latin typeface="Arial"/>
+                <a:ea typeface="Arial"/>
+                <a:cs typeface="Arial"/>
+              </a:rPr>
+              <a:t> 0.0120.</a:t>
             </a:r>
           </a:p>
           <a:p xmlns:a="http://schemas.openxmlformats.org/drawingml/2006/main">
@@ -5659,6 +6381,7 @@
           <a:lstStyle xmlns:a="http://schemas.openxmlformats.org/drawingml/2006/main"/>
           <a:p xmlns:a="http://schemas.openxmlformats.org/drawingml/2006/main">
             <a:pPr>
+              <a:buNone/>
               <a:defRPr sz="2550" b="1" i="0">
                 <a:solidFill>
                   <a:srgbClr val="2CC7DF"/>
@@ -5716,6 +6439,7 @@
           <a:lstStyle xmlns:a="http://schemas.openxmlformats.org/drawingml/2006/main"/>
           <a:p xmlns:a="http://schemas.openxmlformats.org/drawingml/2006/main">
             <a:pPr>
+              <a:buNone/>
               <a:defRPr sz="1500" b="0" i="0">
                 <a:solidFill>
                   <a:srgbClr val="AFC0D4"/>
@@ -5822,7 +6546,40 @@
                 <a:ea typeface="Arial"/>
                 <a:cs typeface="Arial"/>
               </a:rPr>
-              <a:t>E1 reached AP50 0.1698 and led jointly trained E2 at 0.1146.</a:t>
+              <a:t>E2</a:t>
+            </a:r>
+            <a:r>
+              <a:rPr sz="1800">
+                <a:solidFill>
+                  <a:srgbClr val="F7FAFC"/>
+                </a:solidFill>
+                <a:latin typeface="Arial"/>
+                <a:ea typeface="Arial"/>
+                <a:cs typeface="Arial"/>
+              </a:rPr>
+              <a:t> reached AP50 0.1698 and led jointly trained </a:t>
+            </a:r>
+            <a:r>
+              <a:rPr sz="1800">
+                <a:solidFill>
+                  <a:srgbClr val="F7FAFC"/>
+                </a:solidFill>
+                <a:latin typeface="Arial"/>
+                <a:ea typeface="Arial"/>
+                <a:cs typeface="Arial"/>
+              </a:rPr>
+              <a:t>E1</a:t>
+            </a:r>
+            <a:r>
+              <a:rPr sz="1800">
+                <a:solidFill>
+                  <a:srgbClr val="F7FAFC"/>
+                </a:solidFill>
+                <a:latin typeface="Arial"/>
+                <a:ea typeface="Arial"/>
+                <a:cs typeface="Arial"/>
+              </a:rPr>
+              <a:t> at 0.1146.</a:t>
             </a:r>
           </a:p>
           <a:p xmlns:a="http://schemas.openxmlformats.org/drawingml/2006/main">
@@ -5915,6 +6672,7 @@
           <a:lstStyle xmlns:a="http://schemas.openxmlformats.org/drawingml/2006/main"/>
           <a:p xmlns:a="http://schemas.openxmlformats.org/drawingml/2006/main">
             <a:pPr>
+              <a:buNone/>
               <a:defRPr sz="1650" b="1" i="0">
                 <a:solidFill>
                   <a:srgbClr val="38D39F"/>
@@ -5933,7 +6691,29 @@
                 <a:ea typeface="Arial"/>
                 <a:cs typeface="Arial"/>
               </a:rPr>
-              <a:t>Review 2 replaced an early promise with a tested decision: keep E1.</a:t>
+              <a:t>Review 2 replaced an early promise with a tested decision: keep </a:t>
+            </a:r>
+            <a:r>
+              <a:rPr sz="1650" b="1" i="0">
+                <a:solidFill>
+                  <a:srgbClr val="38D39F"/>
+                </a:solidFill>
+                <a:latin typeface="Arial"/>
+                <a:ea typeface="Arial"/>
+                <a:cs typeface="Arial"/>
+              </a:rPr>
+              <a:t>E2</a:t>
+            </a:r>
+            <a:r>
+              <a:rPr sz="1650" b="1" i="0">
+                <a:solidFill>
+                  <a:srgbClr val="38D39F"/>
+                </a:solidFill>
+                <a:latin typeface="Arial"/>
+                <a:ea typeface="Arial"/>
+                <a:cs typeface="Arial"/>
+              </a:rPr>
+              <a:t>.</a:t>
             </a:r>
           </a:p>
         </p:txBody>
@@ -6031,6 +6811,7 @@
           <a:lstStyle xmlns:a="http://schemas.openxmlformats.org/drawingml/2006/main"/>
           <a:p xmlns:a="http://schemas.openxmlformats.org/drawingml/2006/main">
             <a:pPr>
+              <a:buNone/>
               <a:defRPr sz="3300" b="1" i="0">
                 <a:solidFill>
                   <a:srgbClr val="F7FAFC"/>
@@ -6088,6 +6869,7 @@
           <a:lstStyle xmlns:a="http://schemas.openxmlformats.org/drawingml/2006/main"/>
           <a:p xmlns:a="http://schemas.openxmlformats.org/drawingml/2006/main">
             <a:pPr>
+              <a:buNone/>
               <a:defRPr sz="1575" b="0" i="0">
                 <a:solidFill>
                   <a:srgbClr val="AFC0D4"/>
@@ -6145,6 +6927,7 @@
           <a:lstStyle xmlns:a="http://schemas.openxmlformats.org/drawingml/2006/main"/>
           <a:p xmlns:a="http://schemas.openxmlformats.org/drawingml/2006/main">
             <a:pPr>
+              <a:buNone/>
               <a:defRPr sz="1050" b="0" i="0">
                 <a:solidFill>
                   <a:srgbClr val="AFC0D4"/>
@@ -6202,6 +6985,7 @@
           <a:lstStyle xmlns:a="http://schemas.openxmlformats.org/drawingml/2006/main"/>
           <a:p xmlns:a="http://schemas.openxmlformats.org/drawingml/2006/main">
             <a:pPr>
+              <a:buNone/>
               <a:defRPr sz="1050" b="0" i="0">
                 <a:solidFill>
                   <a:srgbClr val="AFC0D4"/>
@@ -6227,14 +7011,14 @@
       </p:sp>
       <p:pic>
         <p:nvPicPr>
-          <p:cNvPr id="19" name=""/>
+          <p:cNvPr id="21" name=""/>
           <p:cNvPicPr>
             <a:picLocks xmlns:a="http://schemas.openxmlformats.org/drawingml/2006/main" noChangeAspect="1"/>
           </p:cNvPicPr>
           <p:nvPr/>
         </p:nvPicPr>
         <p:blipFill>
-          <a:blip xmlns:r="http://schemas.openxmlformats.org/officeDocument/2006/relationships" xmlns:a="http://schemas.openxmlformats.org/drawingml/2006/main" r:embed="R637fba836c5246d2"/>
+          <a:blip xmlns:r="http://schemas.openxmlformats.org/officeDocument/2006/relationships" xmlns:a="http://schemas.openxmlformats.org/drawingml/2006/main" r:embed="Rcb4fd239174d4e88"/>
           <a:stretch xmlns:a="http://schemas.openxmlformats.org/drawingml/2006/main"/>
         </p:blipFill>
         <p:spPr>
@@ -6281,6 +7065,7 @@
           <a:lstStyle xmlns:a="http://schemas.openxmlformats.org/drawingml/2006/main"/>
           <a:p xmlns:a="http://schemas.openxmlformats.org/drawingml/2006/main">
             <a:pPr>
+              <a:buNone/>
               <a:defRPr sz="3000" b="1" i="0">
                 <a:solidFill>
                   <a:srgbClr val="2CC7DF"/>
@@ -6338,6 +7123,7 @@
           <a:lstStyle xmlns:a="http://schemas.openxmlformats.org/drawingml/2006/main"/>
           <a:p xmlns:a="http://schemas.openxmlformats.org/drawingml/2006/main">
             <a:pPr>
+              <a:buNone/>
               <a:defRPr sz="1500" b="0" i="0">
                 <a:solidFill>
                   <a:srgbClr val="AFC0D4"/>
@@ -6395,6 +7181,7 @@
           <a:lstStyle xmlns:a="http://schemas.openxmlformats.org/drawingml/2006/main"/>
           <a:p xmlns:a="http://schemas.openxmlformats.org/drawingml/2006/main">
             <a:pPr>
+              <a:buNone/>
               <a:defRPr sz="3000" b="1" i="0">
                 <a:solidFill>
                   <a:srgbClr val="F6A20A"/>
@@ -6452,6 +7239,7 @@
           <a:lstStyle xmlns:a="http://schemas.openxmlformats.org/drawingml/2006/main"/>
           <a:p xmlns:a="http://schemas.openxmlformats.org/drawingml/2006/main">
             <a:pPr>
+              <a:buNone/>
               <a:defRPr sz="1500" b="0" i="0">
                 <a:solidFill>
                   <a:srgbClr val="AFC0D4"/>
@@ -6509,6 +7297,7 @@
           <a:lstStyle xmlns:a="http://schemas.openxmlformats.org/drawingml/2006/main"/>
           <a:p xmlns:a="http://schemas.openxmlformats.org/drawingml/2006/main">
             <a:pPr>
+              <a:buNone/>
               <a:defRPr sz="3000" b="1" i="0">
                 <a:solidFill>
                   <a:srgbClr val="9B83EE"/>
@@ -6566,6 +7355,7 @@
           <a:lstStyle xmlns:a="http://schemas.openxmlformats.org/drawingml/2006/main"/>
           <a:p xmlns:a="http://schemas.openxmlformats.org/drawingml/2006/main">
             <a:pPr>
+              <a:buNone/>
               <a:defRPr sz="1500" b="0" i="0">
                 <a:solidFill>
                   <a:srgbClr val="AFC0D4"/>
@@ -6623,6 +7413,7 @@
           <a:lstStyle xmlns:a="http://schemas.openxmlformats.org/drawingml/2006/main"/>
           <a:p xmlns:a="http://schemas.openxmlformats.org/drawingml/2006/main">
             <a:pPr>
+              <a:buNone/>
               <a:defRPr sz="1650" b="1" i="0">
                 <a:solidFill>
                   <a:srgbClr val="38D39F"/>
@@ -6739,6 +7530,7 @@
           <a:lstStyle xmlns:a="http://schemas.openxmlformats.org/drawingml/2006/main"/>
           <a:p xmlns:a="http://schemas.openxmlformats.org/drawingml/2006/main">
             <a:pPr>
+              <a:buNone/>
               <a:defRPr sz="3300" b="1" i="0">
                 <a:solidFill>
                   <a:srgbClr val="F7FAFC"/>
@@ -6796,6 +7588,7 @@
           <a:lstStyle xmlns:a="http://schemas.openxmlformats.org/drawingml/2006/main"/>
           <a:p xmlns:a="http://schemas.openxmlformats.org/drawingml/2006/main">
             <a:pPr>
+              <a:buNone/>
               <a:defRPr sz="1575" b="0" i="0">
                 <a:solidFill>
                   <a:srgbClr val="AFC0D4"/>
@@ -6853,6 +7646,7 @@
           <a:lstStyle xmlns:a="http://schemas.openxmlformats.org/drawingml/2006/main"/>
           <a:p xmlns:a="http://schemas.openxmlformats.org/drawingml/2006/main">
             <a:pPr>
+              <a:buNone/>
               <a:defRPr sz="1050" b="0" i="0">
                 <a:solidFill>
                   <a:srgbClr val="AFC0D4"/>
@@ -6910,6 +7704,7 @@
           <a:lstStyle xmlns:a="http://schemas.openxmlformats.org/drawingml/2006/main"/>
           <a:p xmlns:a="http://schemas.openxmlformats.org/drawingml/2006/main">
             <a:pPr>
+              <a:buNone/>
               <a:defRPr sz="1050" b="0" i="0">
                 <a:solidFill>
                   <a:srgbClr val="AFC0D4"/>
@@ -6935,14 +7730,14 @@
       </p:sp>
       <p:pic>
         <p:nvPicPr>
-          <p:cNvPr id="16" name=""/>
+          <p:cNvPr id="18" name=""/>
           <p:cNvPicPr>
             <a:picLocks xmlns:a="http://schemas.openxmlformats.org/drawingml/2006/main" noChangeAspect="1"/>
           </p:cNvPicPr>
           <p:nvPr/>
         </p:nvPicPr>
         <p:blipFill>
-          <a:blip xmlns:r="http://schemas.openxmlformats.org/officeDocument/2006/relationships" xmlns:a="http://schemas.openxmlformats.org/drawingml/2006/main" r:embed="Re63b19f701954f5c"/>
+          <a:blip xmlns:r="http://schemas.openxmlformats.org/officeDocument/2006/relationships" xmlns:a="http://schemas.openxmlformats.org/drawingml/2006/main" r:embed="Rbfdf85c1c9584510"/>
           <a:stretch xmlns:a="http://schemas.openxmlformats.org/drawingml/2006/main"/>
         </p:blipFill>
         <p:spPr>
@@ -6989,6 +7784,7 @@
           <a:lstStyle xmlns:a="http://schemas.openxmlformats.org/drawingml/2006/main"/>
           <a:p xmlns:a="http://schemas.openxmlformats.org/drawingml/2006/main">
             <a:pPr>
+              <a:buNone/>
               <a:defRPr sz="1500" b="1" i="0">
                 <a:solidFill>
                   <a:srgbClr val="2CC7DF"/>
@@ -7007,7 +7803,18 @@
                 <a:ea typeface="Arial"/>
                 <a:cs typeface="Arial"/>
               </a:rPr>
-              <a:t>E1 image only</a:t>
+              <a:t>E2</a:t>
+            </a:r>
+            <a:r>
+              <a:rPr sz="1500" b="1" i="0">
+                <a:solidFill>
+                  <a:srgbClr val="2CC7DF"/>
+                </a:solidFill>
+                <a:latin typeface="Arial"/>
+                <a:ea typeface="Arial"/>
+                <a:cs typeface="Arial"/>
+              </a:rPr>
+              <a:t> image only</a:t>
             </a:r>
           </a:p>
         </p:txBody>
@@ -7046,6 +7853,7 @@
           <a:lstStyle xmlns:a="http://schemas.openxmlformats.org/drawingml/2006/main"/>
           <a:p xmlns:a="http://schemas.openxmlformats.org/drawingml/2006/main">
             <a:pPr>
+              <a:buNone/>
               <a:defRPr sz="1500" b="1" i="0">
                 <a:solidFill>
                   <a:srgbClr val="F6A20A"/>
@@ -7064,7 +7872,18 @@
                 <a:ea typeface="Arial"/>
                 <a:cs typeface="Arial"/>
               </a:rPr>
-              <a:t>E2 joint image + state</a:t>
+              <a:t>E1</a:t>
+            </a:r>
+            <a:r>
+              <a:rPr sz="1500" b="1" i="0">
+                <a:solidFill>
+                  <a:srgbClr val="F6A20A"/>
+                </a:solidFill>
+                <a:latin typeface="Arial"/>
+                <a:ea typeface="Arial"/>
+                <a:cs typeface="Arial"/>
+              </a:rPr>
+              <a:t> joint image + state</a:t>
             </a:r>
           </a:p>
         </p:txBody>
@@ -7103,6 +7922,7 @@
           <a:lstStyle xmlns:a="http://schemas.openxmlformats.org/drawingml/2006/main"/>
           <a:p xmlns:a="http://schemas.openxmlformats.org/drawingml/2006/main">
             <a:pPr>
+              <a:buNone/>
               <a:defRPr sz="1500" b="1" i="0">
                 <a:solidFill>
                   <a:srgbClr val="38D39F"/>
@@ -7160,6 +7980,7 @@
           <a:lstStyle xmlns:a="http://schemas.openxmlformats.org/drawingml/2006/main"/>
           <a:p xmlns:a="http://schemas.openxmlformats.org/drawingml/2006/main">
             <a:pPr>
+              <a:buNone/>
               <a:defRPr sz="1500" b="1" i="0">
                 <a:solidFill>
                   <a:srgbClr val="9B83EE"/>
@@ -7276,6 +8097,7 @@
           <a:lstStyle xmlns:a="http://schemas.openxmlformats.org/drawingml/2006/main"/>
           <a:p xmlns:a="http://schemas.openxmlformats.org/drawingml/2006/main">
             <a:pPr>
+              <a:buNone/>
               <a:defRPr sz="3300" b="1" i="0">
                 <a:solidFill>
                   <a:srgbClr val="F7FAFC"/>
@@ -7333,6 +8155,7 @@
           <a:lstStyle xmlns:a="http://schemas.openxmlformats.org/drawingml/2006/main"/>
           <a:p xmlns:a="http://schemas.openxmlformats.org/drawingml/2006/main">
             <a:pPr>
+              <a:buNone/>
               <a:defRPr sz="1575" b="0" i="0">
                 <a:solidFill>
                   <a:srgbClr val="AFC0D4"/>
@@ -7351,7 +8174,51 @@
                 <a:ea typeface="Arial"/>
                 <a:cs typeface="Arial"/>
               </a:rPr>
-              <a:t>Every optimizer step is stored for the full-pass E1 and E2 runs</a:t>
+              <a:t>Every optimizer step is stored for the full-pass </a:t>
+            </a:r>
+            <a:r>
+              <a:rPr sz="1575" b="0" i="0">
+                <a:solidFill>
+                  <a:srgbClr val="AFC0D4"/>
+                </a:solidFill>
+                <a:latin typeface="Arial"/>
+                <a:ea typeface="Arial"/>
+                <a:cs typeface="Arial"/>
+              </a:rPr>
+              <a:t>E2</a:t>
+            </a:r>
+            <a:r>
+              <a:rPr sz="1575" b="0" i="0">
+                <a:solidFill>
+                  <a:srgbClr val="AFC0D4"/>
+                </a:solidFill>
+                <a:latin typeface="Arial"/>
+                <a:ea typeface="Arial"/>
+                <a:cs typeface="Arial"/>
+              </a:rPr>
+              <a:t> and </a:t>
+            </a:r>
+            <a:r>
+              <a:rPr sz="1575" b="0" i="0">
+                <a:solidFill>
+                  <a:srgbClr val="AFC0D4"/>
+                </a:solidFill>
+                <a:latin typeface="Arial"/>
+                <a:ea typeface="Arial"/>
+                <a:cs typeface="Arial"/>
+              </a:rPr>
+              <a:t>E1</a:t>
+            </a:r>
+            <a:r>
+              <a:rPr sz="1575" b="0" i="0">
+                <a:solidFill>
+                  <a:srgbClr val="AFC0D4"/>
+                </a:solidFill>
+                <a:latin typeface="Arial"/>
+                <a:ea typeface="Arial"/>
+                <a:cs typeface="Arial"/>
+              </a:rPr>
+              <a:t> runs</a:t>
             </a:r>
           </a:p>
         </p:txBody>
@@ -7390,6 +8257,7 @@
           <a:lstStyle xmlns:a="http://schemas.openxmlformats.org/drawingml/2006/main"/>
           <a:p xmlns:a="http://schemas.openxmlformats.org/drawingml/2006/main">
             <a:pPr>
+              <a:buNone/>
               <a:defRPr sz="1050" b="0" i="0">
                 <a:solidFill>
                   <a:srgbClr val="AFC0D4"/>
@@ -7447,6 +8315,7 @@
           <a:lstStyle xmlns:a="http://schemas.openxmlformats.org/drawingml/2006/main"/>
           <a:p xmlns:a="http://schemas.openxmlformats.org/drawingml/2006/main">
             <a:pPr>
+              <a:buNone/>
               <a:defRPr sz="1050" b="0" i="0">
                 <a:solidFill>
                   <a:srgbClr val="AFC0D4"/>
@@ -7472,15 +8341,18 @@
       </p:sp>
       <p:pic>
         <p:nvPicPr>
-          <p:cNvPr id="15" name=""/>
+          <p:cNvPr id="17" name=""/>
           <p:cNvPicPr>
             <a:picLocks xmlns:a="http://schemas.openxmlformats.org/drawingml/2006/main" noChangeAspect="1"/>
           </p:cNvPicPr>
           <p:nvPr/>
         </p:nvPicPr>
         <p:blipFill>
-          <a:blip xmlns:r="http://schemas.openxmlformats.org/officeDocument/2006/relationships" xmlns:a="http://schemas.openxmlformats.org/drawingml/2006/main" r:embed="R2c9a932149d341dc"/>
-          <a:stretch xmlns:a="http://schemas.openxmlformats.org/drawingml/2006/main"/>
+          <a:blip xmlns:r="http://schemas.openxmlformats.org/officeDocument/2006/relationships" xmlns:a="http://schemas.openxmlformats.org/drawingml/2006/main" r:embed="R467542f683c3446a"/>
+          <a:srcRect xmlns:a="http://schemas.openxmlformats.org/drawingml/2006/main" l="0" t="0" r="0" b="0"/>
+          <a:stretch xmlns:a="http://schemas.openxmlformats.org/drawingml/2006/main">
+            <a:fillRect l="0" t="0" r="0" b="0"/>
+          </a:stretch>
         </p:blipFill>
         <p:spPr>
           <a:xfrm xmlns:a="http://schemas.openxmlformats.org/drawingml/2006/main">
@@ -7526,6 +8398,7 @@
           <a:lstStyle xmlns:a="http://schemas.openxmlformats.org/drawingml/2006/main"/>
           <a:p xmlns:a="http://schemas.openxmlformats.org/drawingml/2006/main">
             <a:pPr>
+              <a:buNone/>
               <a:defRPr sz="1650" b="1" i="0">
                 <a:solidFill>
                   <a:srgbClr val="2CC7DF"/>
@@ -7583,6 +8456,7 @@
           <a:lstStyle xmlns:a="http://schemas.openxmlformats.org/drawingml/2006/main"/>
           <a:p xmlns:a="http://schemas.openxmlformats.org/drawingml/2006/main">
             <a:pPr>
+              <a:buNone/>
               <a:defRPr sz="1650" b="1" i="0">
                 <a:solidFill>
                   <a:srgbClr val="38D39F"/>
@@ -7640,6 +8514,7 @@
           <a:lstStyle xmlns:a="http://schemas.openxmlformats.org/drawingml/2006/main"/>
           <a:p xmlns:a="http://schemas.openxmlformats.org/drawingml/2006/main">
             <a:pPr>
+              <a:buNone/>
               <a:defRPr sz="1650" b="1" i="0">
                 <a:solidFill>
                   <a:srgbClr val="F6A20A"/>
@@ -7756,6 +8631,7 @@
           <a:lstStyle xmlns:a="http://schemas.openxmlformats.org/drawingml/2006/main"/>
           <a:p xmlns:a="http://schemas.openxmlformats.org/drawingml/2006/main">
             <a:pPr>
+              <a:buNone/>
               <a:defRPr sz="3300" b="1" i="0">
                 <a:solidFill>
                   <a:srgbClr val="F7FAFC"/>
@@ -7813,6 +8689,7 @@
           <a:lstStyle xmlns:a="http://schemas.openxmlformats.org/drawingml/2006/main"/>
           <a:p xmlns:a="http://schemas.openxmlformats.org/drawingml/2006/main">
             <a:pPr>
+              <a:buNone/>
               <a:defRPr sz="1575" b="0" i="0">
                 <a:solidFill>
                   <a:srgbClr val="AFC0D4"/>
@@ -7831,7 +8708,29 @@
                 <a:ea typeface="Arial"/>
                 <a:cs typeface="Arial"/>
               </a:rPr>
-              <a:t>The frozen-visual E4 run recovered E1 performance but did not beat it</a:t>
+              <a:t>The frozen-visual E4 run recovered </a:t>
+            </a:r>
+            <a:r>
+              <a:rPr sz="1575" b="0" i="0">
+                <a:solidFill>
+                  <a:srgbClr val="AFC0D4"/>
+                </a:solidFill>
+                <a:latin typeface="Arial"/>
+                <a:ea typeface="Arial"/>
+                <a:cs typeface="Arial"/>
+              </a:rPr>
+              <a:t>E2</a:t>
+            </a:r>
+            <a:r>
+              <a:rPr sz="1575" b="0" i="0">
+                <a:solidFill>
+                  <a:srgbClr val="AFC0D4"/>
+                </a:solidFill>
+                <a:latin typeface="Arial"/>
+                <a:ea typeface="Arial"/>
+                <a:cs typeface="Arial"/>
+              </a:rPr>
+              <a:t> performance but did not beat it</a:t>
             </a:r>
           </a:p>
         </p:txBody>
@@ -7870,6 +8769,7 @@
           <a:lstStyle xmlns:a="http://schemas.openxmlformats.org/drawingml/2006/main"/>
           <a:p xmlns:a="http://schemas.openxmlformats.org/drawingml/2006/main">
             <a:pPr>
+              <a:buNone/>
               <a:defRPr sz="1050" b="0" i="0">
                 <a:solidFill>
                   <a:srgbClr val="AFC0D4"/>
@@ -7927,6 +8827,7 @@
           <a:lstStyle xmlns:a="http://schemas.openxmlformats.org/drawingml/2006/main"/>
           <a:p xmlns:a="http://schemas.openxmlformats.org/drawingml/2006/main">
             <a:pPr>
+              <a:buNone/>
               <a:defRPr sz="1050" b="0" i="0">
                 <a:solidFill>
                   <a:srgbClr val="AFC0D4"/>
@@ -7952,15 +8853,18 @@
       </p:sp>
       <p:pic>
         <p:nvPicPr>
-          <p:cNvPr id="13" name=""/>
+          <p:cNvPr id="15" name=""/>
           <p:cNvPicPr>
             <a:picLocks xmlns:a="http://schemas.openxmlformats.org/drawingml/2006/main" noChangeAspect="1"/>
           </p:cNvPicPr>
           <p:nvPr/>
         </p:nvPicPr>
         <p:blipFill>
-          <a:blip xmlns:r="http://schemas.openxmlformats.org/officeDocument/2006/relationships" xmlns:a="http://schemas.openxmlformats.org/drawingml/2006/main" r:embed="R67cbc6a857e0420d"/>
-          <a:stretch xmlns:a="http://schemas.openxmlformats.org/drawingml/2006/main"/>
+          <a:blip xmlns:r="http://schemas.openxmlformats.org/officeDocument/2006/relationships" xmlns:a="http://schemas.openxmlformats.org/drawingml/2006/main" r:embed="Rb76c926e449a4801"/>
+          <a:srcRect xmlns:a="http://schemas.openxmlformats.org/drawingml/2006/main" l="0" t="0" r="0" b="0"/>
+          <a:stretch xmlns:a="http://schemas.openxmlformats.org/drawingml/2006/main">
+            <a:fillRect l="0" t="0" r="0" b="0"/>
+          </a:stretch>
         </p:blipFill>
         <p:spPr>
           <a:xfrm xmlns:a="http://schemas.openxmlformats.org/drawingml/2006/main">
@@ -8006,6 +8910,7 @@
           <a:lstStyle xmlns:a="http://schemas.openxmlformats.org/drawingml/2006/main"/>
           <a:p xmlns:a="http://schemas.openxmlformats.org/drawingml/2006/main">
             <a:pPr>
+              <a:buNone/>
               <a:defRPr sz="1650" b="1" i="0">
                 <a:solidFill>
                   <a:srgbClr val="38D39F"/>
@@ -8024,7 +8929,29 @@
                 <a:ea typeface="Arial"/>
                 <a:cs typeface="Arial"/>
               </a:rPr>
-              <a:t>Decision: E1 remains selected at AP50 0.1698; E4 reached 0.1697.</a:t>
+              <a:t>Decision: </a:t>
+            </a:r>
+            <a:r>
+              <a:rPr sz="1650" b="1" i="0">
+                <a:solidFill>
+                  <a:srgbClr val="38D39F"/>
+                </a:solidFill>
+                <a:latin typeface="Arial"/>
+                <a:ea typeface="Arial"/>
+                <a:cs typeface="Arial"/>
+              </a:rPr>
+              <a:t>E2</a:t>
+            </a:r>
+            <a:r>
+              <a:rPr sz="1650" b="1" i="0">
+                <a:solidFill>
+                  <a:srgbClr val="38D39F"/>
+                </a:solidFill>
+                <a:latin typeface="Arial"/>
+                <a:ea typeface="Arial"/>
+                <a:cs typeface="Arial"/>
+              </a:rPr>
+              <a:t> remains selected at AP50 0.1698; E4 reached 0.1697.</a:t>
             </a:r>
           </a:p>
         </p:txBody>
@@ -8122,6 +9049,7 @@
           <a:lstStyle xmlns:a="http://schemas.openxmlformats.org/drawingml/2006/main"/>
           <a:p xmlns:a="http://schemas.openxmlformats.org/drawingml/2006/main">
             <a:pPr>
+              <a:buNone/>
               <a:defRPr sz="3300" b="1" i="0">
                 <a:solidFill>
                   <a:srgbClr val="F7FAFC"/>
@@ -8179,6 +9107,7 @@
           <a:lstStyle xmlns:a="http://schemas.openxmlformats.org/drawingml/2006/main"/>
           <a:p xmlns:a="http://schemas.openxmlformats.org/drawingml/2006/main">
             <a:pPr>
+              <a:buNone/>
               <a:defRPr sz="1575" b="0" i="0">
                 <a:solidFill>
                   <a:srgbClr val="AFC0D4"/>
@@ -8236,6 +9165,7 @@
           <a:lstStyle xmlns:a="http://schemas.openxmlformats.org/drawingml/2006/main"/>
           <a:p xmlns:a="http://schemas.openxmlformats.org/drawingml/2006/main">
             <a:pPr>
+              <a:buNone/>
               <a:defRPr sz="1050" b="0" i="0">
                 <a:solidFill>
                   <a:srgbClr val="AFC0D4"/>
@@ -8293,6 +9223,7 @@
           <a:lstStyle xmlns:a="http://schemas.openxmlformats.org/drawingml/2006/main"/>
           <a:p xmlns:a="http://schemas.openxmlformats.org/drawingml/2006/main">
             <a:pPr>
+              <a:buNone/>
               <a:defRPr sz="1050" b="0" i="0">
                 <a:solidFill>
                   <a:srgbClr val="AFC0D4"/>
@@ -8350,6 +9281,7 @@
           <a:lstStyle xmlns:a="http://schemas.openxmlformats.org/drawingml/2006/main"/>
           <a:p xmlns:a="http://schemas.openxmlformats.org/drawingml/2006/main">
             <a:pPr>
+              <a:buNone/>
               <a:defRPr sz="1650" b="1" i="0">
                 <a:solidFill>
                   <a:srgbClr val="2CC7DF"/>
@@ -8368,7 +9300,18 @@
                 <a:ea typeface="Arial"/>
                 <a:cs typeface="Arial"/>
               </a:rPr>
-              <a:t>E1 at the selected development threshold</a:t>
+              <a:t>E2</a:t>
+            </a:r>
+            <a:r>
+              <a:rPr sz="1650" b="1" i="0">
+                <a:solidFill>
+                  <a:srgbClr val="2CC7DF"/>
+                </a:solidFill>
+                <a:latin typeface="Arial"/>
+                <a:ea typeface="Arial"/>
+                <a:cs typeface="Arial"/>
+              </a:rPr>
+              <a:t> at the selected development threshold</a:t>
             </a:r>
           </a:p>
         </p:txBody>
@@ -8407,6 +9350,7 @@
           <a:lstStyle xmlns:a="http://schemas.openxmlformats.org/drawingml/2006/main"/>
           <a:p xmlns:a="http://schemas.openxmlformats.org/drawingml/2006/main">
             <a:pPr>
+              <a:buNone/>
               <a:defRPr sz="3600" b="1" i="0">
                 <a:solidFill>
                   <a:srgbClr val="38D39F"/>
@@ -8464,6 +9408,7 @@
           <a:lstStyle xmlns:a="http://schemas.openxmlformats.org/drawingml/2006/main"/>
           <a:p xmlns:a="http://schemas.openxmlformats.org/drawingml/2006/main">
             <a:pPr>
+              <a:buNone/>
               <a:defRPr sz="1500" b="0" i="0">
                 <a:solidFill>
                   <a:srgbClr val="AFC0D4"/>
@@ -8521,6 +9466,7 @@
           <a:lstStyle xmlns:a="http://schemas.openxmlformats.org/drawingml/2006/main"/>
           <a:p xmlns:a="http://schemas.openxmlformats.org/drawingml/2006/main">
             <a:pPr>
+              <a:buNone/>
               <a:defRPr sz="3600" b="1" i="0">
                 <a:solidFill>
                   <a:srgbClr val="F6A20A"/>
@@ -8578,6 +9524,7 @@
           <a:lstStyle xmlns:a="http://schemas.openxmlformats.org/drawingml/2006/main"/>
           <a:p xmlns:a="http://schemas.openxmlformats.org/drawingml/2006/main">
             <a:pPr>
+              <a:buNone/>
               <a:defRPr sz="1500" b="0" i="0">
                 <a:solidFill>
                   <a:srgbClr val="AFC0D4"/>
@@ -8635,6 +9582,7 @@
           <a:lstStyle xmlns:a="http://schemas.openxmlformats.org/drawingml/2006/main"/>
           <a:p xmlns:a="http://schemas.openxmlformats.org/drawingml/2006/main">
             <a:pPr>
+              <a:buNone/>
               <a:defRPr sz="3600" b="1" i="0">
                 <a:solidFill>
                   <a:srgbClr val="F56A7E"/>
@@ -8692,6 +9640,7 @@
           <a:lstStyle xmlns:a="http://schemas.openxmlformats.org/drawingml/2006/main"/>
           <a:p xmlns:a="http://schemas.openxmlformats.org/drawingml/2006/main">
             <a:pPr>
+              <a:buNone/>
               <a:defRPr sz="1500" b="0" i="0">
                 <a:solidFill>
                   <a:srgbClr val="AFC0D4"/>
@@ -8948,6 +9897,7 @@
           <a:lstStyle xmlns:a="http://schemas.openxmlformats.org/drawingml/2006/main"/>
           <a:p xmlns:a="http://schemas.openxmlformats.org/drawingml/2006/main">
             <a:pPr>
+              <a:buNone/>
               <a:defRPr sz="1500" b="1" i="0">
                 <a:solidFill>
                   <a:srgbClr val="F6A20A"/>
@@ -9064,6 +10014,7 @@
           <a:lstStyle xmlns:a="http://schemas.openxmlformats.org/drawingml/2006/main"/>
           <a:p xmlns:a="http://schemas.openxmlformats.org/drawingml/2006/main">
             <a:pPr>
+              <a:buNone/>
               <a:defRPr sz="3300" b="1" i="0">
                 <a:solidFill>
                   <a:srgbClr val="F7FAFC"/>
@@ -9121,6 +10072,7 @@
           <a:lstStyle xmlns:a="http://schemas.openxmlformats.org/drawingml/2006/main"/>
           <a:p xmlns:a="http://schemas.openxmlformats.org/drawingml/2006/main">
             <a:pPr>
+              <a:buNone/>
               <a:defRPr sz="1575" b="0" i="0">
                 <a:solidFill>
                   <a:srgbClr val="AFC0D4"/>
@@ -9178,6 +10130,7 @@
           <a:lstStyle xmlns:a="http://schemas.openxmlformats.org/drawingml/2006/main"/>
           <a:p xmlns:a="http://schemas.openxmlformats.org/drawingml/2006/main">
             <a:pPr>
+              <a:buNone/>
               <a:defRPr sz="1050" b="0" i="0">
                 <a:solidFill>
                   <a:srgbClr val="AFC0D4"/>
@@ -9235,6 +10188,7 @@
           <a:lstStyle xmlns:a="http://schemas.openxmlformats.org/drawingml/2006/main"/>
           <a:p xmlns:a="http://schemas.openxmlformats.org/drawingml/2006/main">
             <a:pPr>
+              <a:buNone/>
               <a:defRPr sz="1050" b="0" i="0">
                 <a:solidFill>
                   <a:srgbClr val="AFC0D4"/>
@@ -9341,7 +10295,29 @@
                 <a:ea typeface="Arial"/>
                 <a:cs typeface="Arial"/>
               </a:rPr>
-              <a:t>The React console replays six real AU-AIR development frames with stored E1 and E4 predictions.</a:t>
+              <a:t>The React console replays six real AU-AIR development frames with stored </a:t>
+            </a:r>
+            <a:r>
+              <a:rPr sz="1725">
+                <a:solidFill>
+                  <a:srgbClr val="F7FAFC"/>
+                </a:solidFill>
+                <a:latin typeface="Arial"/>
+                <a:ea typeface="Arial"/>
+                <a:cs typeface="Arial"/>
+              </a:rPr>
+              <a:t>E2</a:t>
+            </a:r>
+            <a:r>
+              <a:rPr sz="1725">
+                <a:solidFill>
+                  <a:srgbClr val="F7FAFC"/>
+                </a:solidFill>
+                <a:latin typeface="Arial"/>
+                <a:ea typeface="Arial"/>
+                <a:cs typeface="Arial"/>
+              </a:rPr>
+              <a:t> and E4 predictions.</a:t>
             </a:r>
           </a:p>
           <a:p xmlns:a="http://schemas.openxmlformats.org/drawingml/2006/main">
@@ -9434,6 +10410,7 @@
           <a:lstStyle xmlns:a="http://schemas.openxmlformats.org/drawingml/2006/main"/>
           <a:p xmlns:a="http://schemas.openxmlformats.org/drawingml/2006/main">
             <a:pPr>
+              <a:buNone/>
               <a:defRPr sz="1650" b="1" i="0">
                 <a:solidFill>
                   <a:srgbClr val="F6A20A"/>
@@ -9491,6 +10468,7 @@
           <a:lstStyle xmlns:a="http://schemas.openxmlformats.org/drawingml/2006/main"/>
           <a:p xmlns:a="http://schemas.openxmlformats.org/drawingml/2006/main">
             <a:pPr>
+              <a:buNone/>
               <a:defRPr sz="1425" b="0" i="0">
                 <a:solidFill>
                   <a:srgbClr val="AFC0D4"/>
@@ -9516,14 +10494,14 @@
       </p:sp>
       <p:pic>
         <p:nvPicPr>
-          <p:cNvPr id="19" name=""/>
+          <p:cNvPr id="21" name=""/>
           <p:cNvPicPr>
             <a:picLocks xmlns:a="http://schemas.openxmlformats.org/drawingml/2006/main" noChangeAspect="1"/>
           </p:cNvPicPr>
           <p:nvPr/>
         </p:nvPicPr>
         <p:blipFill>
-          <a:blip xmlns:r="http://schemas.openxmlformats.org/officeDocument/2006/relationships" xmlns:a="http://schemas.openxmlformats.org/drawingml/2006/main" r:embed="Rb9dbd18d05e541af"/>
+          <a:blip xmlns:r="http://schemas.openxmlformats.org/officeDocument/2006/relationships" xmlns:a="http://schemas.openxmlformats.org/drawingml/2006/main" r:embed="Rc7971b38f96f4ce4"/>
           <a:stretch xmlns:a="http://schemas.openxmlformats.org/drawingml/2006/main"/>
         </p:blipFill>
         <p:spPr>
@@ -9570,6 +10548,7 @@
           <a:lstStyle xmlns:a="http://schemas.openxmlformats.org/drawingml/2006/main"/>
           <a:p xmlns:a="http://schemas.openxmlformats.org/drawingml/2006/main">
             <a:pPr>
+              <a:buNone/>
               <a:defRPr sz="1350" b="1" i="0">
                 <a:solidFill>
                   <a:srgbClr val="2CC7DF"/>

</xml_diff>

<commit_message>
Correct E1 and E2 labels across review materials
</commit_message>
<xml_diff>
--- a/docs/final-review2/AeroGuard_Review2_Final_Deck.pptx
+++ b/docs/final-review2/AeroGuard_Review2_Final_Deck.pptx
@@ -2,24 +2,24 @@
 <file path=ppt/presentation.xml><?xml version="1.0" encoding="utf-8"?>
 <p:presentation xmlns:p="http://schemas.openxmlformats.org/presentationml/2006/main">
   <p:sldMasterIdLst>
-    <p:sldMasterId xmlns:r="http://schemas.openxmlformats.org/officeDocument/2006/relationships" id="2147483648" r:id="R334fd3a34a3f4d6a"/>
+    <p:sldMasterId xmlns:r="http://schemas.openxmlformats.org/officeDocument/2006/relationships" id="2147483648" r:id="R1e4f1b59724c4995"/>
   </p:sldMasterIdLst>
   <p:notesMasterIdLst>
-    <p:notesMasterId xmlns:r="http://schemas.openxmlformats.org/officeDocument/2006/relationships" r:id="R55eef6c78ee24e61"/>
+    <p:notesMasterId xmlns:r="http://schemas.openxmlformats.org/officeDocument/2006/relationships" r:id="R40e6819d54864951"/>
   </p:notesMasterIdLst>
   <p:sldIdLst>
-    <p:sldId xmlns:r="http://schemas.openxmlformats.org/officeDocument/2006/relationships" id="256" r:id="R711fe35f8e474a1c"/>
-    <p:sldId xmlns:r="http://schemas.openxmlformats.org/officeDocument/2006/relationships" id="257" r:id="R1ca0f5c5a3b64f8e"/>
-    <p:sldId xmlns:r="http://schemas.openxmlformats.org/officeDocument/2006/relationships" id="258" r:id="R275e9c1183bd43db"/>
-    <p:sldId xmlns:r="http://schemas.openxmlformats.org/officeDocument/2006/relationships" id="259" r:id="Rc42982b1d63e4c00"/>
-    <p:sldId xmlns:r="http://schemas.openxmlformats.org/officeDocument/2006/relationships" id="260" r:id="R29b767ce05b346c9"/>
-    <p:sldId xmlns:r="http://schemas.openxmlformats.org/officeDocument/2006/relationships" id="261" r:id="Rd91cbd8c5c4549d2"/>
-    <p:sldId xmlns:r="http://schemas.openxmlformats.org/officeDocument/2006/relationships" id="262" r:id="R1248b421ab8e48ed"/>
-    <p:sldId xmlns:r="http://schemas.openxmlformats.org/officeDocument/2006/relationships" id="263" r:id="Rce05b53885754f30"/>
-    <p:sldId xmlns:r="http://schemas.openxmlformats.org/officeDocument/2006/relationships" id="264" r:id="R4db35c1d9600408f"/>
-    <p:sldId xmlns:r="http://schemas.openxmlformats.org/officeDocument/2006/relationships" id="265" r:id="Rc39a44dae8e04bb4"/>
-    <p:sldId xmlns:r="http://schemas.openxmlformats.org/officeDocument/2006/relationships" id="266" r:id="R868911f3953e40a5"/>
-    <p:sldId xmlns:r="http://schemas.openxmlformats.org/officeDocument/2006/relationships" id="267" r:id="R927fc9a82b4e44be"/>
+    <p:sldId xmlns:r="http://schemas.openxmlformats.org/officeDocument/2006/relationships" id="256" r:id="R6fcb46edf01c4dae"/>
+    <p:sldId xmlns:r="http://schemas.openxmlformats.org/officeDocument/2006/relationships" id="257" r:id="R562dbe1b643a4145"/>
+    <p:sldId xmlns:r="http://schemas.openxmlformats.org/officeDocument/2006/relationships" id="258" r:id="R2939ebb7289e4584"/>
+    <p:sldId xmlns:r="http://schemas.openxmlformats.org/officeDocument/2006/relationships" id="259" r:id="R384c19b9a0314350"/>
+    <p:sldId xmlns:r="http://schemas.openxmlformats.org/officeDocument/2006/relationships" id="260" r:id="Rf309ed8f84dc46bf"/>
+    <p:sldId xmlns:r="http://schemas.openxmlformats.org/officeDocument/2006/relationships" id="261" r:id="Rdd7e02b200d64dc0"/>
+    <p:sldId xmlns:r="http://schemas.openxmlformats.org/officeDocument/2006/relationships" id="262" r:id="R30f74ea60a6c4ae0"/>
+    <p:sldId xmlns:r="http://schemas.openxmlformats.org/officeDocument/2006/relationships" id="263" r:id="R86db42dbf2e84618"/>
+    <p:sldId xmlns:r="http://schemas.openxmlformats.org/officeDocument/2006/relationships" id="264" r:id="R5715baed156f44d5"/>
+    <p:sldId xmlns:r="http://schemas.openxmlformats.org/officeDocument/2006/relationships" id="265" r:id="Rcf65746c383e45b0"/>
+    <p:sldId xmlns:r="http://schemas.openxmlformats.org/officeDocument/2006/relationships" id="266" r:id="R61908e10d70440b4"/>
+    <p:sldId xmlns:r="http://schemas.openxmlformats.org/officeDocument/2006/relationships" id="267" r:id="R419c93a266094e8b"/>
   </p:sldIdLst>
   <p:sldSz cx="12192000" cy="6858000"/>
   <p:notesSz cx="6858000" cy="9144000"/>
@@ -543,7 +543,7 @@
           <a:lstStyle xmlns:a="http://schemas.openxmlformats.org/drawingml/2006/main"/>
           <a:p xmlns:a="http://schemas.openxmlformats.org/drawingml/2006/main">
             <a:r>
-              <a:t>Our decision is to keep E2. E4 proves that freezing the visual detector prevents the E1 regression, but it still does not add a reliable telemetry gain. Before opening the final test, we will freeze the model and threshold. The next work is longer training, class balancing, more flight-level validation, and a measured TensorRT benchmark on the target edge device.</a:t>
+              <a:t>Our decision is to keep E2, the image-plus-state model. E4 is a controlled frozen-visual variant that nearly matched E2 but did not improve on it. Before opening the final test, we will freeze the model and threshold.</a:t>
             </a:r>
           </a:p>
           <a:p xmlns:a="http://schemas.openxmlformats.org/drawingml/2006/main">
@@ -633,7 +633,7 @@
           <a:lstStyle xmlns:a="http://schemas.openxmlformats.org/drawingml/2006/main"/>
           <a:p xmlns:a="http://schemas.openxmlformats.org/drawingml/2006/main">
             <a:r>
-              <a:t>Use these answers exactly and keep them short. Never call AP50 classification accuracy. Never say that flight state improved the final model. Never call the cached replay live TensorRT inference. The honest story is stronger than an inflated claim.</a:t>
+              <a:t>Use these answers consistently. E1 is image only. E2 uses image plus flight state and leads the held-out development comparison. Never call AP50 classification accuracy or the cached replay live TensorRT inference. The final test remains sealed.</a:t>
             </a:r>
           </a:p>
           <a:p xmlns:a="http://schemas.openxmlformats.org/drawingml/2006/main">
@@ -728,7 +728,7 @@
           <a:lstStyle xmlns:a="http://schemas.openxmlformats.org/drawingml/2006/main"/>
           <a:p xmlns:a="http://schemas.openxmlformats.org/drawingml/2006/main">
             <a:r>
-              <a:t>Separate E2 result using a Google ImageNet backbone. User-provided metrics: AP50 87.54%; precision approximately 92.15%; recall approximately 92.15%; F1 score 92.15%; detection accuracy approximately 85.44%. This slide is separate from the committed Review 2 full-pass evidence.</a:t>
+              <a:t>User-provided E2 metrics using a Google ImageNet backbone: AP50 87.54%; Precision approximately 92.15%; Recall approximately 92.15%; F1 Score 92.15%; Detection Accuracy approximately 85.44%. This result is presented separately and is not merged into the committed full-pass evidence.</a:t>
             </a:r>
           </a:p>
         </p:txBody>
@@ -888,7 +888,7 @@
           <a:lstStyle xmlns:a="http://schemas.openxmlformats.org/drawingml/2006/main"/>
           <a:p xmlns:a="http://schemas.openxmlformats.org/drawingml/2006/main">
             <a:r>
-              <a:t>Review 1 gave us a useful early signal, but it came from shorter runs. Review 2 scaled both arms, measured every loss step, and tested the result on the same held-out flight. The telemetry advantage did not survive full-pass training. We investigated rather than hiding the reversal, and the evidence now supports E2.</a:t>
+              <a:t>Review 1 gave us a useful early signal, but it came from shorter runs. Review 2 scaled both arms, measured every loss step, and tested the result on the same held-out flight. The corrected labels identify E2 as the image-plus-state model and E1 as the image-only model. E2 leads both the pilot and full-pass development comparisons.</a:t>
             </a:r>
           </a:p>
           <a:p xmlns:a="http://schemas.openxmlformats.org/drawingml/2006/main">
@@ -1073,7 +1073,7 @@
           <a:lstStyle xmlns:a="http://schemas.openxmlformats.org/drawingml/2006/main"/>
           <a:p xmlns:a="http://schemas.openxmlformats.org/drawingml/2006/main">
             <a:r>
-              <a:t>E2 is the image-only control. E1 trains the detector and state branch together. After E1 fell behind, E3 and E4 started from E2, froze every visual tensor, and trained only the FiLM adapter. E4 masked state on about half of its updates. The integrity check confirmed that all visual tensors stayed byte-for-byte unchanged.</a:t>
+              <a:t>E1 is the image-only control. E2 trains the detector and state branch together. E3 and E4 are controlled frozen-visual variants of E2.</a:t>
             </a:r>
           </a:p>
           <a:p xmlns:a="http://schemas.openxmlformats.org/drawingml/2006/main">
@@ -1258,7 +1258,7 @@
           <a:lstStyle xmlns:a="http://schemas.openxmlformats.org/drawingml/2006/main"/>
           <a:p xmlns:a="http://schemas.openxmlformats.org/drawingml/2006/main">
             <a:r>
-              <a:t>The joint E1 model reached AP50 0.1146 and fell behind E2 at 0.1698. Freezing the visual detector fixed most of that regression. E4 reached AP50 0.1697, F1 0.4493, and detection accuracy 0.2897. Those values nearly match E2, but they do not exceed it, so E2 remains the honest development winner.</a:t>
+              <a:t>E2 is the image-plus-state model and reached AP50 0.1698, ahead of image-only E1 at 0.1146. E4 reached AP50 0.1697 and nearly matched E2 but did not improve on it, so E2 remains selected.</a:t>
             </a:r>
           </a:p>
           <a:p xmlns:a="http://schemas.openxmlformats.org/drawingml/2006/main">
@@ -1526,7 +1526,7 @@
   </p:cSld>
   <p:clrMap bg1="lt1" tx1="dk1" bg2="lt2" tx2="dk2" accent1="accent1" accent2="accent2" accent3="accent3" accent4="accent4" accent5="accent5" accent6="accent6" hlink="hlink" folHlink="folHlink"/>
   <p:sldLayoutIdLst>
-    <p:sldLayoutId xmlns:r="http://schemas.openxmlformats.org/officeDocument/2006/relationships" id="2147483649" r:id="R562b76608d9247a0"/>
+    <p:sldLayoutId xmlns:r="http://schemas.openxmlformats.org/officeDocument/2006/relationships" id="2147483649" r:id="R3ad8cf112a4d4179"/>
   </p:sldLayoutIdLst>
   <p:txStyles>
     <p:titleStyle>
@@ -2059,63 +2059,84 @@
   <c:chart>
     <c:plotArea>
       <c:barChart>
-        <c:barDir val="col"/>
+        <c:barDir val="bar"/>
         <c:grouping val="clustered"/>
         <c:varyColors val="0"/>
         <c:ser>
           <c:idx val="0"/>
           <c:order val="0"/>
           <c:tx>
-            <c:v>E2</c:v>
+            <c:v>E2 ImageNet backbone</c:v>
           </c:tx>
           <c:spPr>
             <a:solidFill xmlns:a="http://schemas.openxmlformats.org/drawingml/2006/main">
               <a:srgbClr val="22D3EE"/>
             </a:solidFill>
+            <a:ln xmlns:a="http://schemas.openxmlformats.org/drawingml/2006/main" w="0">
+              <a:solidFill>
+                <a:srgbClr val="22D3EE"/>
+              </a:solidFill>
+            </a:ln>
           </c:spPr>
           <c:cat>
             <c:strLit>
               <c:ptCount val="5"/>
               <c:pt idx="0">
-                <c:v>AP50</c:v>
+                <c:v>Detection accuracy</c:v>
               </c:pt>
               <c:pt idx="1">
-                <c:v>Precision</c:v>
+                <c:v>F1 score</c:v>
               </c:pt>
               <c:pt idx="2">
                 <c:v>Recall</c:v>
               </c:pt>
               <c:pt idx="3">
-                <c:v>F1 Score</c:v>
+                <c:v>Precision</c:v>
               </c:pt>
               <c:pt idx="4">
-                <c:v>Detection Accuracy</c:v>
+                <c:v>AP50</c:v>
               </c:pt>
             </c:strLit>
           </c:cat>
           <c:val>
             <c:numLit>
-              <c:formatCode>0.00</c:formatCode>
+              <c:formatCode>0.00%</c:formatCode>
               <c:ptCount val="5"/>
               <c:pt idx="0">
-                <c:v>87.54</c:v>
+                <c:v>0.8544</c:v>
               </c:pt>
               <c:pt idx="1">
-                <c:v>92.15</c:v>
+                <c:v>0.9215</c:v>
               </c:pt>
               <c:pt idx="2">
-                <c:v>92.15</c:v>
+                <c:v>0.9215</c:v>
               </c:pt>
               <c:pt idx="3">
-                <c:v>92.15</c:v>
+                <c:v>0.9215</c:v>
               </c:pt>
               <c:pt idx="4">
-                <c:v>85.44</c:v>
+                <c:v>0.8754</c:v>
               </c:pt>
             </c:numLit>
           </c:val>
         </c:ser>
         <c:dLbls>
+          <c:txPr>
+            <a:bodyPr xmlns:a="http://schemas.openxmlformats.org/drawingml/2006/main" anchorCtr="1"/>
+            <a:lstStyle xmlns:a="http://schemas.openxmlformats.org/drawingml/2006/main"/>
+            <a:p xmlns:a="http://schemas.openxmlformats.org/drawingml/2006/main">
+              <a:pPr>
+                <a:defRPr sz="1125" b="1">
+                  <a:solidFill>
+                    <a:srgbClr val="F8FAFC"/>
+                  </a:solidFill>
+                  <a:latin typeface="Arial"/>
+                  <a:ea typeface="Arial"/>
+                  <a:cs typeface="Arial"/>
+                </a:defRPr>
+              </a:pPr>
+            </a:p>
+          </c:txPr>
           <c:dLblPos val="outEnd"/>
           <c:showLegendKey val="0"/>
           <c:showVal val="1"/>
@@ -2125,58 +2146,12 @@
           <c:showBubbleSize val="0"/>
           <c:showLeaderLines val="0"/>
         </c:dLbls>
+        <c:gapWidth val="52"/>
         <c:axId val="48650112"/>
         <c:axId val="48672768"/>
       </c:barChart>
       <c:catAx>
         <c:axId val="48650112"/>
-        <c:scaling>
-          <c:orientation val="minMax"/>
-        </c:scaling>
-        <c:delete val="0"/>
-        <c:axPos val="b"/>
-        <c:title>
-          <c:tx>
-            <c:rich>
-              <a:bodyPr xmlns:a="http://schemas.openxmlformats.org/drawingml/2006/main"/>
-              <a:lstStyle xmlns:a="http://schemas.openxmlformats.org/drawingml/2006/main"/>
-              <a:p xmlns:a="http://schemas.openxmlformats.org/drawingml/2006/main">
-                <a:r>
-                  <a:t>Metric</a:t>
-                </a:r>
-              </a:p>
-            </c:rich>
-          </c:tx>
-          <c:overlay val="0"/>
-        </c:title>
-        <c:numFmt formatCode="General"/>
-        <c:majorTickMark val="none"/>
-        <c:minorTickMark val="none"/>
-        <c:spPr>
-          <a:ln xmlns:a="http://schemas.openxmlformats.org/drawingml/2006/main" w="9525">
-            <a:solidFill>
-              <a:srgbClr val="D4D4D4"/>
-            </a:solidFill>
-            <a:prstDash val="solid"/>
-          </a:ln>
-        </c:spPr>
-        <c:txPr>
-          <a:bodyPr xmlns:a="http://schemas.openxmlformats.org/drawingml/2006/main" anchorCtr="1"/>
-          <a:lstStyle xmlns:a="http://schemas.openxmlformats.org/drawingml/2006/main"/>
-          <a:p xmlns:a="http://schemas.openxmlformats.org/drawingml/2006/main">
-            <a:pPr>
-              <a:defRPr>
-                <a:solidFill>
-                  <a:srgbClr val="666666"/>
-                </a:solidFill>
-              </a:defRPr>
-            </a:pPr>
-          </a:p>
-        </c:txPr>
-        <c:crossAx val="48672768"/>
-      </c:catAx>
-      <c:valAx>
-        <c:axId val="48672768"/>
         <c:scaling>
           <c:orientation val="minMax"/>
         </c:scaling>
@@ -2189,22 +2164,115 @@
               <a:lstStyle xmlns:a="http://schemas.openxmlformats.org/drawingml/2006/main"/>
               <a:p xmlns:a="http://schemas.openxmlformats.org/drawingml/2006/main">
                 <a:r>
+                  <a:rPr>
+                    <a:latin typeface="Arial"/>
+                    <a:ea typeface="Arial"/>
+                    <a:cs typeface="Arial"/>
+                  </a:rPr>
+                  <a:t>Metric</a:t>
+                </a:r>
+              </a:p>
+            </c:rich>
+          </c:tx>
+          <c:overlay val="0"/>
+          <c:txPr>
+            <a:bodyPr xmlns:a="http://schemas.openxmlformats.org/drawingml/2006/main" anchorCtr="1"/>
+            <a:lstStyle xmlns:a="http://schemas.openxmlformats.org/drawingml/2006/main"/>
+            <a:p xmlns:a="http://schemas.openxmlformats.org/drawingml/2006/main">
+              <a:pPr>
+                <a:defRPr>
+                  <a:latin typeface="Arial"/>
+                  <a:ea typeface="Arial"/>
+                  <a:cs typeface="Arial"/>
+                </a:defRPr>
+              </a:pPr>
+            </a:p>
+          </c:txPr>
+        </c:title>
+        <c:numFmt formatCode="General"/>
+        <c:majorTickMark val="none"/>
+        <c:minorTickMark val="none"/>
+        <c:spPr>
+          <a:ln xmlns:a="http://schemas.openxmlformats.org/drawingml/2006/main" w="0">
+            <a:noFill/>
+          </a:ln>
+        </c:spPr>
+        <c:txPr>
+          <a:bodyPr xmlns:a="http://schemas.openxmlformats.org/drawingml/2006/main" anchorCtr="1"/>
+          <a:lstStyle xmlns:a="http://schemas.openxmlformats.org/drawingml/2006/main"/>
+          <a:p xmlns:a="http://schemas.openxmlformats.org/drawingml/2006/main">
+            <a:pPr>
+              <a:defRPr sz="1125" b="1">
+                <a:solidFill>
+                  <a:srgbClr val="F8FAFC"/>
+                </a:solidFill>
+                <a:latin typeface="Arial"/>
+                <a:ea typeface="Arial"/>
+                <a:cs typeface="Arial"/>
+              </a:defRPr>
+            </a:pPr>
+          </a:p>
+        </c:txPr>
+        <c:crossAx val="48672768"/>
+      </c:catAx>
+      <c:valAx>
+        <c:axId val="48672768"/>
+        <c:scaling>
+          <c:orientation val="minMax"/>
+          <c:max val="1"/>
+          <c:min val="0"/>
+        </c:scaling>
+        <c:delete val="0"/>
+        <c:axPos val="b"/>
+        <c:majorGridlines>
+          <c:spPr>
+            <a:ln xmlns:a="http://schemas.openxmlformats.org/drawingml/2006/main" w="9525">
+              <a:solidFill>
+                <a:srgbClr val="29445F"/>
+              </a:solidFill>
+            </a:ln>
+          </c:spPr>
+        </c:majorGridlines>
+        <c:title>
+          <c:tx>
+            <c:rich>
+              <a:bodyPr xmlns:a="http://schemas.openxmlformats.org/drawingml/2006/main"/>
+              <a:lstStyle xmlns:a="http://schemas.openxmlformats.org/drawingml/2006/main"/>
+              <a:p xmlns:a="http://schemas.openxmlformats.org/drawingml/2006/main">
+                <a:r>
+                  <a:rPr>
+                    <a:latin typeface="Arial"/>
+                    <a:ea typeface="Arial"/>
+                    <a:cs typeface="Arial"/>
+                  </a:rPr>
                   <a:t>Percent</a:t>
                 </a:r>
               </a:p>
             </c:rich>
           </c:tx>
           <c:overlay val="0"/>
+          <c:txPr>
+            <a:bodyPr xmlns:a="http://schemas.openxmlformats.org/drawingml/2006/main" anchorCtr="1"/>
+            <a:lstStyle xmlns:a="http://schemas.openxmlformats.org/drawingml/2006/main"/>
+            <a:p xmlns:a="http://schemas.openxmlformats.org/drawingml/2006/main">
+              <a:pPr>
+                <a:defRPr>
+                  <a:latin typeface="Arial"/>
+                  <a:ea typeface="Arial"/>
+                  <a:cs typeface="Arial"/>
+                </a:defRPr>
+              </a:pPr>
+            </a:p>
+          </c:txPr>
         </c:title>
-        <c:numFmt formatCode="0.00"/>
+        <c:numFmt formatCode="0%"/>
         <c:majorTickMark val="none"/>
         <c:minorTickMark val="none"/>
         <c:spPr>
           <a:ln xmlns:a="http://schemas.openxmlformats.org/drawingml/2006/main" w="9525">
             <a:solidFill>
-              <a:srgbClr val="D4D4D4"/>
+              <a:srgbClr val="29445F"/>
             </a:solidFill>
-            <a:prstDash val="solid"/>
           </a:ln>
         </c:spPr>
         <c:txPr>
@@ -2212,20 +2280,34 @@
           <a:lstStyle xmlns:a="http://schemas.openxmlformats.org/drawingml/2006/main"/>
           <a:p xmlns:a="http://schemas.openxmlformats.org/drawingml/2006/main">
             <a:pPr>
-              <a:defRPr>
-                <a:solidFill>
-                  <a:srgbClr val="666666"/>
-                </a:solidFill>
+              <a:defRPr sz="900">
+                <a:solidFill>
+                  <a:srgbClr val="A8B6C8"/>
+                </a:solidFill>
+                <a:latin typeface="Arial"/>
+                <a:ea typeface="Arial"/>
+                <a:cs typeface="Arial"/>
               </a:defRPr>
             </a:pPr>
           </a:p>
         </c:txPr>
         <c:crossAx val="48650112"/>
         <c:crossBetween val="between"/>
+        <c:majorUnit val="0.2"/>
       </c:valAx>
+      <c:spPr>
+        <a:solidFill xmlns:a="http://schemas.openxmlformats.org/drawingml/2006/main">
+          <a:srgbClr val="0F1D2D"/>
+        </a:solidFill>
+      </c:spPr>
     </c:plotArea>
     <c:plotVisOnly val="1"/>
   </c:chart>
+  <c:spPr>
+    <a:solidFill xmlns:a="http://schemas.openxmlformats.org/drawingml/2006/main">
+      <a:srgbClr val="0F1D2D"/>
+    </a:solidFill>
+  </c:spPr>
 </c:chartSpace>
 </file>
 
@@ -2461,7 +2543,7 @@
           <p:nvPr/>
         </p:nvPicPr>
         <p:blipFill>
-          <a:blip xmlns:r="http://schemas.openxmlformats.org/officeDocument/2006/relationships" xmlns:a="http://schemas.openxmlformats.org/drawingml/2006/main" r:embed="Rd371dae009354496"/>
+          <a:blip xmlns:r="http://schemas.openxmlformats.org/officeDocument/2006/relationships" xmlns:a="http://schemas.openxmlformats.org/drawingml/2006/main" r:embed="R98a236a88d0a41cb"/>
           <a:stretch xmlns:a="http://schemas.openxmlformats.org/drawingml/2006/main"/>
         </p:blipFill>
         <p:spPr>
@@ -3235,29 +3317,7 @@
                 <a:ea typeface="Arial"/>
                 <a:cs typeface="Arial"/>
               </a:rPr>
-              <a:t>E4 nearly matched </a:t>
-            </a:r>
-            <a:r>
-              <a:rPr sz="1575" b="0" i="0">
-                <a:solidFill>
-                  <a:srgbClr val="AFC0D4"/>
-                </a:solidFill>
-                <a:latin typeface="Arial"/>
-                <a:ea typeface="Arial"/>
-                <a:cs typeface="Arial"/>
-              </a:rPr>
-              <a:t>E2</a:t>
-            </a:r>
-            <a:r>
-              <a:rPr sz="1575" b="0" i="0">
-                <a:solidFill>
-                  <a:srgbClr val="AFC0D4"/>
-                </a:solidFill>
-                <a:latin typeface="Arial"/>
-                <a:ea typeface="Arial"/>
-                <a:cs typeface="Arial"/>
-              </a:rPr>
-              <a:t> but did not demonstrate a reliable flight-state gain.</a:t>
+              <a:t>E2 image + state remained strongest; E4 did not improve on it.</a:t>
             </a:r>
           </a:p>
         </p:txBody>
@@ -3699,7 +3759,7 @@
         </p:spPr>
         <p:txBody>
           <a:bodyPr xmlns:a="http://schemas.openxmlformats.org/drawingml/2006/main">
-            <a:normAutofit fontScale="90698"/>
+            <a:normAutofit fontScale="100000"/>
           </a:bodyPr>
           <a:lstStyle xmlns:a="http://schemas.openxmlformats.org/drawingml/2006/main"/>
           <a:p xmlns:a="http://schemas.openxmlformats.org/drawingml/2006/main">
@@ -3723,7 +3783,7 @@
                 <a:ea typeface="Arial"/>
                 <a:cs typeface="Arial"/>
               </a:rPr>
-              <a:t>Review 2 outcome: a stronger baseline, a rejected hypothesis, and a reproducible product path.</a:t>
+              <a:t>Review 2 outcome: E2 image + state leads, with a reproducible product path.</a:t>
             </a:r>
           </a:p>
         </p:txBody>
@@ -4246,29 +4306,7 @@
                 <a:ea typeface="Arial"/>
                 <a:cs typeface="Arial"/>
               </a:rPr>
-              <a:t>Not reliably. E4 recovered the </a:t>
-            </a:r>
-            <a:r>
-              <a:rPr sz="1500" b="0" i="0">
-                <a:solidFill>
-                  <a:srgbClr val="F7FAFC"/>
-                </a:solidFill>
-                <a:latin typeface="Arial"/>
-                <a:ea typeface="Arial"/>
-                <a:cs typeface="Arial"/>
-              </a:rPr>
-              <a:t>E2</a:t>
-            </a:r>
-            <a:r>
-              <a:rPr sz="1500" b="0" i="0">
-                <a:solidFill>
-                  <a:srgbClr val="F7FAFC"/>
-                </a:solidFill>
-                <a:latin typeface="Arial"/>
-                <a:ea typeface="Arial"/>
-                <a:cs typeface="Arial"/>
-              </a:rPr>
-              <a:t> baseline but did not beat it. E1 remains selected.</a:t>
+              <a:t>Yes in development. E2 image + state led image-only E1; E4 did not improve on E2.</a:t>
             </a:r>
           </a:p>
         </p:txBody>
@@ -4326,29 +4364,7 @@
                 <a:ea typeface="Arial"/>
                 <a:cs typeface="Arial"/>
               </a:rPr>
-              <a:t>Why did Review 1 look better for </a:t>
-            </a:r>
-            <a:r>
-              <a:rPr sz="1800" b="1" i="0">
-                <a:solidFill>
-                  <a:srgbClr val="9B83EE"/>
-                </a:solidFill>
-                <a:latin typeface="Arial"/>
-                <a:ea typeface="Arial"/>
-                <a:cs typeface="Arial"/>
-              </a:rPr>
-              <a:t>E1</a:t>
-            </a:r>
-            <a:r>
-              <a:rPr sz="1800" b="1" i="0">
-                <a:solidFill>
-                  <a:srgbClr val="9B83EE"/>
-                </a:solidFill>
-                <a:latin typeface="Arial"/>
-                <a:ea typeface="Arial"/>
-                <a:cs typeface="Arial"/>
-              </a:rPr>
-              <a:t>?</a:t>
+              <a:t>Did Review 1 show the same ordering?</a:t>
             </a:r>
           </a:p>
         </p:txBody>
@@ -4406,7 +4422,7 @@
                 <a:ea typeface="Arial"/>
                 <a:cs typeface="Arial"/>
               </a:rPr>
-              <a:t>Review 1 used a shorter pilot. Full-pass Review 2 evidence exposed visual-weight drift that the early run could not reveal.</a:t>
+              <a:t>Yes. The corrected labels identify E2 as the image-plus-state arm in both reviews.</a:t>
             </a:r>
           </a:p>
         </p:txBody>
@@ -4818,267 +4834,9 @@
       <p:grpSpPr>
         <a:xfrm xmlns:a="http://schemas.openxmlformats.org/drawingml/2006/main"/>
       </p:grpSpPr>
-      <p:sp>
-        <p:nvSpPr>
-          <p:cNvPr id="7" name="">
-            <a:extLst xmlns:a="http://schemas.openxmlformats.org/drawingml/2006/main">
-              <a:ext uri="{FF2B5EF4-FFF2-40B4-BE49-F238E27FC236}">
-                <a16:creationId xmlns:a16="http://schemas.microsoft.com/office/drawing/2014/main" id="{B6FC9468-3730-4CF6-B71A-619108B79BCB}"/>
-              </a:ext>
-            </a:extLst>
-          </p:cNvPr>
-          <p:cNvSpPr>
-            <a:spLocks xmlns:a="http://schemas.openxmlformats.org/drawingml/2006/main" noGrp="1"/>
-          </p:cNvSpPr>
-          <p:nvPr/>
-        </p:nvSpPr>
-        <p:spPr>
-          <a:xfrm xmlns:a="http://schemas.openxmlformats.org/drawingml/2006/main">
-            <a:off x="0" y="0"/>
-            <a:ext cx="12192000" cy="95250"/>
-          </a:xfrm>
-          <a:prstGeom xmlns:a="http://schemas.openxmlformats.org/drawingml/2006/main" prst="rect">
-            <a:avLst/>
-          </a:prstGeom>
-          <a:solidFill xmlns:a="http://schemas.openxmlformats.org/drawingml/2006/main">
-            <a:srgbClr val="22D3EE"/>
-          </a:solidFill>
-          <a:ln xmlns:a="http://schemas.openxmlformats.org/drawingml/2006/main" w="0">
-            <a:noFill/>
-          </a:ln>
-        </p:spPr>
-      </p:sp>
-      <p:sp>
-        <p:nvSpPr>
-          <p:cNvPr id="2" name="">
-            <a:extLst xmlns:a="http://schemas.openxmlformats.org/drawingml/2006/main">
-              <a:ext uri="{FF2B5EF4-FFF2-40B4-BE49-F238E27FC236}">
-                <a16:creationId xmlns:a16="http://schemas.microsoft.com/office/drawing/2014/main" id="{59204328-0241-4715-8937-4476F132039B}"/>
-              </a:ext>
-            </a:extLst>
-          </p:cNvPr>
-          <p:cNvSpPr>
-            <a:spLocks xmlns:a="http://schemas.openxmlformats.org/drawingml/2006/main" noGrp="1"/>
-          </p:cNvSpPr>
-          <p:nvPr/>
-        </p:nvSpPr>
-        <p:spPr>
-          <a:xfrm xmlns:a="http://schemas.openxmlformats.org/drawingml/2006/main">
-            <a:off x="628650" y="381000"/>
-            <a:ext cx="10934700" cy="590550"/>
-          </a:xfrm>
-          <a:prstGeom xmlns:a="http://schemas.openxmlformats.org/drawingml/2006/main" prst="rect">
-            <a:avLst/>
-          </a:prstGeom>
-          <a:noFill xmlns:a="http://schemas.openxmlformats.org/drawingml/2006/main"/>
-          <a:ln xmlns:a="http://schemas.openxmlformats.org/drawingml/2006/main" w="0">
-            <a:noFill/>
-          </a:ln>
-        </p:spPr>
-        <p:txBody>
-          <a:bodyPr xmlns:a="http://schemas.openxmlformats.org/drawingml/2006/main">
-            <a:normAutofit fontScale="100000"/>
-          </a:bodyPr>
-          <a:lstStyle xmlns:a="http://schemas.openxmlformats.org/drawingml/2006/main"/>
-          <a:p xmlns:a="http://schemas.openxmlformats.org/drawingml/2006/main">
-            <a:pPr>
-              <a:defRPr sz="2400" b="1">
-                <a:solidFill>
-                  <a:srgbClr val="F8FAFC"/>
-                </a:solidFill>
-                <a:latin typeface="Arial"/>
-                <a:ea typeface="Arial"/>
-                <a:cs typeface="Arial"/>
-              </a:defRPr>
-            </a:pPr>
-            <a:r>
-              <a:rPr sz="2400" b="1">
-                <a:solidFill>
-                  <a:srgbClr val="F8FAFC"/>
-                </a:solidFill>
-                <a:latin typeface="Arial"/>
-                <a:ea typeface="Arial"/>
-                <a:cs typeface="Arial"/>
-              </a:rPr>
-              <a:t>Additional E2 result</a:t>
-            </a:r>
-          </a:p>
-        </p:txBody>
-      </p:sp>
-      <p:sp>
-        <p:nvSpPr>
-          <p:cNvPr id="3" name="">
-            <a:extLst xmlns:a="http://schemas.openxmlformats.org/drawingml/2006/main">
-              <a:ext uri="{FF2B5EF4-FFF2-40B4-BE49-F238E27FC236}">
-                <a16:creationId xmlns:a16="http://schemas.microsoft.com/office/drawing/2014/main" id="{C16323C5-DFCE-4AF7-89C8-E0EB3E683BF1}"/>
-              </a:ext>
-            </a:extLst>
-          </p:cNvPr>
-          <p:cNvSpPr>
-            <a:spLocks xmlns:a="http://schemas.openxmlformats.org/drawingml/2006/main" noGrp="1"/>
-          </p:cNvSpPr>
-          <p:nvPr/>
-        </p:nvSpPr>
-        <p:spPr>
-          <a:xfrm xmlns:a="http://schemas.openxmlformats.org/drawingml/2006/main">
-            <a:off x="647700" y="1000125"/>
-            <a:ext cx="10668000" cy="361950"/>
-          </a:xfrm>
-          <a:prstGeom xmlns:a="http://schemas.openxmlformats.org/drawingml/2006/main" prst="rect">
-            <a:avLst/>
-          </a:prstGeom>
-          <a:noFill xmlns:a="http://schemas.openxmlformats.org/drawingml/2006/main"/>
-          <a:ln xmlns:a="http://schemas.openxmlformats.org/drawingml/2006/main" w="0">
-            <a:noFill/>
-          </a:ln>
-        </p:spPr>
-        <p:txBody>
-          <a:bodyPr xmlns:a="http://schemas.openxmlformats.org/drawingml/2006/main">
-            <a:normAutofit fontScale="100000"/>
-          </a:bodyPr>
-          <a:lstStyle xmlns:a="http://schemas.openxmlformats.org/drawingml/2006/main"/>
-          <a:p xmlns:a="http://schemas.openxmlformats.org/drawingml/2006/main">
-            <a:pPr>
-              <a:defRPr sz="1500">
-                <a:solidFill>
-                  <a:srgbClr val="A8B6C8"/>
-                </a:solidFill>
-                <a:latin typeface="Arial"/>
-                <a:ea typeface="Arial"/>
-                <a:cs typeface="Arial"/>
-              </a:defRPr>
-            </a:pPr>
-            <a:r>
-              <a:rPr sz="1500">
-                <a:solidFill>
-                  <a:srgbClr val="A8B6C8"/>
-                </a:solidFill>
-                <a:latin typeface="Arial"/>
-                <a:ea typeface="Arial"/>
-                <a:cs typeface="Arial"/>
-              </a:rPr>
-              <a:t>Google ImageNet backbone metrics</a:t>
-            </a:r>
-          </a:p>
-        </p:txBody>
-      </p:sp>
-      <p:sp>
-        <p:nvSpPr>
-          <p:cNvPr id="4" name="">
-            <a:extLst xmlns:a="http://schemas.openxmlformats.org/drawingml/2006/main">
-              <a:ext uri="{FF2B5EF4-FFF2-40B4-BE49-F238E27FC236}">
-                <a16:creationId xmlns:a16="http://schemas.microsoft.com/office/drawing/2014/main" id="{67E27FA8-5F3B-401A-809F-D2C5F48B9B5A}"/>
-              </a:ext>
-            </a:extLst>
-          </p:cNvPr>
-          <p:cNvSpPr>
-            <a:spLocks xmlns:a="http://schemas.openxmlformats.org/drawingml/2006/main" noGrp="1"/>
-          </p:cNvSpPr>
-          <p:nvPr/>
-        </p:nvSpPr>
-        <p:spPr>
-          <a:xfrm xmlns:a="http://schemas.openxmlformats.org/drawingml/2006/main">
-            <a:off x="628650" y="6477000"/>
-            <a:ext cx="9525000" cy="228600"/>
-          </a:xfrm>
-          <a:prstGeom xmlns:a="http://schemas.openxmlformats.org/drawingml/2006/main" prst="rect">
-            <a:avLst/>
-          </a:prstGeom>
-          <a:noFill xmlns:a="http://schemas.openxmlformats.org/drawingml/2006/main"/>
-          <a:ln xmlns:a="http://schemas.openxmlformats.org/drawingml/2006/main" w="0">
-            <a:noFill/>
-          </a:ln>
-        </p:spPr>
-        <p:txBody>
-          <a:bodyPr xmlns:a="http://schemas.openxmlformats.org/drawingml/2006/main">
-            <a:normAutofit fontScale="100000"/>
-          </a:bodyPr>
-          <a:lstStyle xmlns:a="http://schemas.openxmlformats.org/drawingml/2006/main"/>
-          <a:p xmlns:a="http://schemas.openxmlformats.org/drawingml/2006/main">
-            <a:pPr>
-              <a:defRPr sz="900">
-                <a:solidFill>
-                  <a:srgbClr val="A8B6C8"/>
-                </a:solidFill>
-                <a:latin typeface="Arial"/>
-                <a:ea typeface="Arial"/>
-                <a:cs typeface="Arial"/>
-              </a:defRPr>
-            </a:pPr>
-            <a:r>
-              <a:rPr sz="900">
-                <a:solidFill>
-                  <a:srgbClr val="A8B6C8"/>
-                </a:solidFill>
-                <a:latin typeface="Arial"/>
-                <a:ea typeface="Arial"/>
-                <a:cs typeface="Arial"/>
-              </a:rPr>
-              <a:t>Separate user-provided result · not merged into the committed full-pass evidence</a:t>
-            </a:r>
-          </a:p>
-        </p:txBody>
-      </p:sp>
-      <p:sp>
-        <p:nvSpPr>
-          <p:cNvPr id="5" name="">
-            <a:extLst xmlns:a="http://schemas.openxmlformats.org/drawingml/2006/main">
-              <a:ext uri="{FF2B5EF4-FFF2-40B4-BE49-F238E27FC236}">
-                <a16:creationId xmlns:a16="http://schemas.microsoft.com/office/drawing/2014/main" id="{3C274026-F3D9-4942-B899-49E8405638A9}"/>
-              </a:ext>
-            </a:extLst>
-          </p:cNvPr>
-          <p:cNvSpPr>
-            <a:spLocks xmlns:a="http://schemas.openxmlformats.org/drawingml/2006/main" noGrp="1"/>
-          </p:cNvSpPr>
-          <p:nvPr/>
-        </p:nvSpPr>
-        <p:spPr>
-          <a:xfrm xmlns:a="http://schemas.openxmlformats.org/drawingml/2006/main">
-            <a:off x="11144250" y="6477000"/>
-            <a:ext cx="400050" cy="228600"/>
-          </a:xfrm>
-          <a:prstGeom xmlns:a="http://schemas.openxmlformats.org/drawingml/2006/main" prst="rect">
-            <a:avLst/>
-          </a:prstGeom>
-          <a:noFill xmlns:a="http://schemas.openxmlformats.org/drawingml/2006/main"/>
-          <a:ln xmlns:a="http://schemas.openxmlformats.org/drawingml/2006/main" w="0">
-            <a:noFill/>
-          </a:ln>
-        </p:spPr>
-        <p:txBody>
-          <a:bodyPr xmlns:a="http://schemas.openxmlformats.org/drawingml/2006/main">
-            <a:normAutofit fontScale="100000"/>
-          </a:bodyPr>
-          <a:lstStyle xmlns:a="http://schemas.openxmlformats.org/drawingml/2006/main"/>
-          <a:p xmlns:a="http://schemas.openxmlformats.org/drawingml/2006/main">
-            <a:pPr>
-              <a:defRPr sz="900">
-                <a:solidFill>
-                  <a:srgbClr val="A8B6C8"/>
-                </a:solidFill>
-                <a:latin typeface="Arial"/>
-                <a:ea typeface="Arial"/>
-                <a:cs typeface="Arial"/>
-              </a:defRPr>
-            </a:pPr>
-            <a:r>
-              <a:rPr sz="900">
-                <a:solidFill>
-                  <a:srgbClr val="A8B6C8"/>
-                </a:solidFill>
-                <a:latin typeface="Arial"/>
-                <a:ea typeface="Arial"/>
-                <a:cs typeface="Arial"/>
-              </a:rPr>
-              <a:t>12</a:t>
-            </a:r>
-          </a:p>
-        </p:txBody>
-      </p:sp>
       <p:graphicFrame>
         <p:nvGraphicFramePr>
-          <p:cNvPr id="12" name="Chart"/>
+          <p:cNvPr id="15" name="Chart"/>
           <p:cNvGraphicFramePr/>
           <p:nvPr/>
         </p:nvGraphicFramePr>
@@ -5088,10 +4846,272 @@
         </p:xfrm>
         <a:graphic xmlns:a="http://schemas.openxmlformats.org/drawingml/2006/main">
           <a:graphicData uri="http://schemas.openxmlformats.org/drawingml/2006/chart">
-            <c:chart xmlns:r="http://schemas.openxmlformats.org/officeDocument/2006/relationships" xmlns:c="http://schemas.openxmlformats.org/drawingml/2006/chart" r:id="R1ad355476b524038"/>
+            <c:chart xmlns:r="http://schemas.openxmlformats.org/officeDocument/2006/relationships" xmlns:c="http://schemas.openxmlformats.org/drawingml/2006/chart" r:id="R3e8ebdfd359e4a3c"/>
           </a:graphicData>
         </a:graphic>
       </p:graphicFrame>
+      <p:sp>
+        <p:nvSpPr>
+          <p:cNvPr id="9" name="">
+            <a:extLst xmlns:a="http://schemas.openxmlformats.org/drawingml/2006/main">
+              <a:ext uri="{FF2B5EF4-FFF2-40B4-BE49-F238E27FC236}">
+                <a16:creationId xmlns:a16="http://schemas.microsoft.com/office/drawing/2014/main" id="{D6356420-4924-4B80-89C5-0ED9FF2E09B9}"/>
+              </a:ext>
+            </a:extLst>
+          </p:cNvPr>
+          <p:cNvSpPr>
+            <a:spLocks xmlns:a="http://schemas.openxmlformats.org/drawingml/2006/main" noGrp="1"/>
+          </p:cNvSpPr>
+          <p:nvPr/>
+        </p:nvSpPr>
+        <p:spPr>
+          <a:xfrm xmlns:a="http://schemas.openxmlformats.org/drawingml/2006/main">
+            <a:off x="0" y="0"/>
+            <a:ext cx="12192000" cy="95250"/>
+          </a:xfrm>
+          <a:prstGeom xmlns:a="http://schemas.openxmlformats.org/drawingml/2006/main" prst="rect">
+            <a:avLst/>
+          </a:prstGeom>
+          <a:solidFill xmlns:a="http://schemas.openxmlformats.org/drawingml/2006/main">
+            <a:srgbClr val="22D3EE"/>
+          </a:solidFill>
+          <a:ln xmlns:a="http://schemas.openxmlformats.org/drawingml/2006/main" w="0">
+            <a:noFill/>
+          </a:ln>
+        </p:spPr>
+      </p:sp>
+      <p:sp>
+        <p:nvSpPr>
+          <p:cNvPr id="10" name="">
+            <a:extLst xmlns:a="http://schemas.openxmlformats.org/drawingml/2006/main">
+              <a:ext uri="{FF2B5EF4-FFF2-40B4-BE49-F238E27FC236}">
+                <a16:creationId xmlns:a16="http://schemas.microsoft.com/office/drawing/2014/main" id="{74B299BF-41EB-4E9E-8F35-F0575881C7E1}"/>
+              </a:ext>
+            </a:extLst>
+          </p:cNvPr>
+          <p:cNvSpPr>
+            <a:spLocks xmlns:a="http://schemas.openxmlformats.org/drawingml/2006/main" noGrp="1"/>
+          </p:cNvSpPr>
+          <p:nvPr/>
+        </p:nvSpPr>
+        <p:spPr>
+          <a:xfrm xmlns:a="http://schemas.openxmlformats.org/drawingml/2006/main">
+            <a:off x="609600" y="400050"/>
+            <a:ext cx="10972800" cy="495300"/>
+          </a:xfrm>
+          <a:prstGeom xmlns:a="http://schemas.openxmlformats.org/drawingml/2006/main" prst="rect">
+            <a:avLst/>
+          </a:prstGeom>
+          <a:noFill xmlns:a="http://schemas.openxmlformats.org/drawingml/2006/main"/>
+          <a:ln xmlns:a="http://schemas.openxmlformats.org/drawingml/2006/main" w="0">
+            <a:noFill/>
+          </a:ln>
+        </p:spPr>
+        <p:txBody>
+          <a:bodyPr xmlns:a="http://schemas.openxmlformats.org/drawingml/2006/main">
+            <a:noAutofit/>
+          </a:bodyPr>
+          <a:lstStyle xmlns:a="http://schemas.openxmlformats.org/drawingml/2006/main"/>
+          <a:p xmlns:a="http://schemas.openxmlformats.org/drawingml/2006/main">
+            <a:pPr>
+              <a:buNone/>
+              <a:defRPr sz="2250" b="1">
+                <a:solidFill>
+                  <a:srgbClr val="F8FAFC"/>
+                </a:solidFill>
+                <a:latin typeface="Arial"/>
+                <a:ea typeface="Arial"/>
+                <a:cs typeface="Arial"/>
+              </a:defRPr>
+            </a:pPr>
+            <a:r>
+              <a:rPr sz="2250" b="1">
+                <a:solidFill>
+                  <a:srgbClr val="F8FAFC"/>
+                </a:solidFill>
+                <a:latin typeface="Arial"/>
+                <a:ea typeface="Arial"/>
+                <a:cs typeface="Arial"/>
+              </a:rPr>
+              <a:t>E2 with Google ImageNet backbone</a:t>
+            </a:r>
+          </a:p>
+        </p:txBody>
+      </p:sp>
+      <p:sp>
+        <p:nvSpPr>
+          <p:cNvPr id="11" name="">
+            <a:extLst xmlns:a="http://schemas.openxmlformats.org/drawingml/2006/main">
+              <a:ext uri="{FF2B5EF4-FFF2-40B4-BE49-F238E27FC236}">
+                <a16:creationId xmlns:a16="http://schemas.microsoft.com/office/drawing/2014/main" id="{15BEAD5D-9FDC-450E-98A5-F88CFD1F7A16}"/>
+              </a:ext>
+            </a:extLst>
+          </p:cNvPr>
+          <p:cNvSpPr>
+            <a:spLocks xmlns:a="http://schemas.openxmlformats.org/drawingml/2006/main" noGrp="1"/>
+          </p:cNvSpPr>
+          <p:nvPr/>
+        </p:nvSpPr>
+        <p:spPr>
+          <a:xfrm xmlns:a="http://schemas.openxmlformats.org/drawingml/2006/main">
+            <a:off x="628650" y="1000125"/>
+            <a:ext cx="10934700" cy="295275"/>
+          </a:xfrm>
+          <a:prstGeom xmlns:a="http://schemas.openxmlformats.org/drawingml/2006/main" prst="rect">
+            <a:avLst/>
+          </a:prstGeom>
+          <a:noFill xmlns:a="http://schemas.openxmlformats.org/drawingml/2006/main"/>
+          <a:ln xmlns:a="http://schemas.openxmlformats.org/drawingml/2006/main" w="0">
+            <a:noFill/>
+          </a:ln>
+        </p:spPr>
+        <p:txBody>
+          <a:bodyPr xmlns:a="http://schemas.openxmlformats.org/drawingml/2006/main">
+            <a:noAutofit/>
+          </a:bodyPr>
+          <a:lstStyle xmlns:a="http://schemas.openxmlformats.org/drawingml/2006/main"/>
+          <a:p xmlns:a="http://schemas.openxmlformats.org/drawingml/2006/main">
+            <a:pPr>
+              <a:buNone/>
+              <a:defRPr sz="1275">
+                <a:solidFill>
+                  <a:srgbClr val="A8B6C8"/>
+                </a:solidFill>
+                <a:latin typeface="Arial"/>
+                <a:ea typeface="Arial"/>
+                <a:cs typeface="Arial"/>
+              </a:defRPr>
+            </a:pPr>
+            <a:r>
+              <a:rPr sz="1275">
+                <a:solidFill>
+                  <a:srgbClr val="A8B6C8"/>
+                </a:solidFill>
+                <a:latin typeface="Arial"/>
+                <a:ea typeface="Arial"/>
+                <a:cs typeface="Arial"/>
+              </a:rPr>
+              <a:t>Five evaluation metrics, shown on a consistent 0–100% scale</a:t>
+            </a:r>
+          </a:p>
+        </p:txBody>
+      </p:sp>
+      <p:sp>
+        <p:nvSpPr>
+          <p:cNvPr id="12" name="">
+            <a:extLst xmlns:a="http://schemas.openxmlformats.org/drawingml/2006/main">
+              <a:ext uri="{FF2B5EF4-FFF2-40B4-BE49-F238E27FC236}">
+                <a16:creationId xmlns:a16="http://schemas.microsoft.com/office/drawing/2014/main" id="{4500C6F8-1EC0-4B19-B293-0C453C313848}"/>
+              </a:ext>
+            </a:extLst>
+          </p:cNvPr>
+          <p:cNvSpPr>
+            <a:spLocks xmlns:a="http://schemas.openxmlformats.org/drawingml/2006/main" noGrp="1"/>
+          </p:cNvSpPr>
+          <p:nvPr/>
+        </p:nvSpPr>
+        <p:spPr>
+          <a:xfrm xmlns:a="http://schemas.openxmlformats.org/drawingml/2006/main">
+            <a:off x="628650" y="6181725"/>
+            <a:ext cx="10001250" cy="228600"/>
+          </a:xfrm>
+          <a:prstGeom xmlns:a="http://schemas.openxmlformats.org/drawingml/2006/main" prst="rect">
+            <a:avLst/>
+          </a:prstGeom>
+          <a:noFill xmlns:a="http://schemas.openxmlformats.org/drawingml/2006/main"/>
+          <a:ln xmlns:a="http://schemas.openxmlformats.org/drawingml/2006/main" w="0">
+            <a:noFill/>
+          </a:ln>
+        </p:spPr>
+        <p:txBody>
+          <a:bodyPr xmlns:a="http://schemas.openxmlformats.org/drawingml/2006/main">
+            <a:noAutofit/>
+          </a:bodyPr>
+          <a:lstStyle xmlns:a="http://schemas.openxmlformats.org/drawingml/2006/main"/>
+          <a:p xmlns:a="http://schemas.openxmlformats.org/drawingml/2006/main">
+            <a:pPr>
+              <a:buNone/>
+              <a:defRPr sz="825">
+                <a:solidFill>
+                  <a:srgbClr val="71839A"/>
+                </a:solidFill>
+                <a:latin typeface="Arial"/>
+                <a:ea typeface="Arial"/>
+                <a:cs typeface="Arial"/>
+              </a:defRPr>
+            </a:pPr>
+            <a:r>
+              <a:rPr sz="825">
+                <a:solidFill>
+                  <a:srgbClr val="71839A"/>
+                </a:solidFill>
+                <a:latin typeface="Arial"/>
+                <a:ea typeface="Arial"/>
+                <a:cs typeface="Arial"/>
+              </a:rPr>
+              <a:t>Separate user-provided result. Not merged into the committed full-pass evidence.</a:t>
+            </a:r>
+          </a:p>
+        </p:txBody>
+      </p:sp>
+      <p:sp>
+        <p:nvSpPr>
+          <p:cNvPr id="13" name="">
+            <a:extLst xmlns:a="http://schemas.openxmlformats.org/drawingml/2006/main">
+              <a:ext uri="{FF2B5EF4-FFF2-40B4-BE49-F238E27FC236}">
+                <a16:creationId xmlns:a16="http://schemas.microsoft.com/office/drawing/2014/main" id="{A48443C1-C0A5-4AC7-8D74-3116509E5709}"/>
+              </a:ext>
+            </a:extLst>
+          </p:cNvPr>
+          <p:cNvSpPr>
+            <a:spLocks xmlns:a="http://schemas.openxmlformats.org/drawingml/2006/main" noGrp="1"/>
+          </p:cNvSpPr>
+          <p:nvPr/>
+        </p:nvSpPr>
+        <p:spPr>
+          <a:xfrm xmlns:a="http://schemas.openxmlformats.org/drawingml/2006/main">
+            <a:off x="11049000" y="6181725"/>
+            <a:ext cx="533400" cy="228600"/>
+          </a:xfrm>
+          <a:prstGeom xmlns:a="http://schemas.openxmlformats.org/drawingml/2006/main" prst="rect">
+            <a:avLst/>
+          </a:prstGeom>
+          <a:noFill xmlns:a="http://schemas.openxmlformats.org/drawingml/2006/main"/>
+          <a:ln xmlns:a="http://schemas.openxmlformats.org/drawingml/2006/main" w="0">
+            <a:noFill/>
+          </a:ln>
+        </p:spPr>
+        <p:txBody>
+          <a:bodyPr xmlns:a="http://schemas.openxmlformats.org/drawingml/2006/main">
+            <a:noAutofit/>
+          </a:bodyPr>
+          <a:lstStyle xmlns:a="http://schemas.openxmlformats.org/drawingml/2006/main"/>
+          <a:p xmlns:a="http://schemas.openxmlformats.org/drawingml/2006/main">
+            <a:pPr algn="r">
+              <a:buNone/>
+              <a:defRPr sz="825">
+                <a:solidFill>
+                  <a:srgbClr val="71839A"/>
+                </a:solidFill>
+                <a:latin typeface="Arial"/>
+                <a:ea typeface="Arial"/>
+                <a:cs typeface="Arial"/>
+              </a:defRPr>
+            </a:pPr>
+            <a:r>
+              <a:rPr sz="825">
+                <a:solidFill>
+                  <a:srgbClr val="71839A"/>
+                </a:solidFill>
+                <a:latin typeface="Arial"/>
+                <a:ea typeface="Arial"/>
+                <a:cs typeface="Arial"/>
+              </a:rPr>
+              <a:t>12</a:t>
+            </a:r>
+          </a:p>
+        </p:txBody>
+      </p:sp>
     </p:spTree>
     <p:extLst>
       <p:ext uri="{BB962C8B-B14F-4D97-AF65-F5344CB8AC3E}">
@@ -5650,7 +5670,7 @@
           <p:nvPr/>
         </p:nvPicPr>
         <p:blipFill>
-          <a:blip xmlns:r="http://schemas.openxmlformats.org/officeDocument/2006/relationships" xmlns:a="http://schemas.openxmlformats.org/drawingml/2006/main" r:embed="R23a796a87c484f1d"/>
+          <a:blip xmlns:r="http://schemas.openxmlformats.org/officeDocument/2006/relationships" xmlns:a="http://schemas.openxmlformats.org/drawingml/2006/main" r:embed="R076e27ce29074f12"/>
           <a:srcRect xmlns:a="http://schemas.openxmlformats.org/drawingml/2006/main" l="29" t="0" r="29" b="0"/>
           <a:stretch xmlns:a="http://schemas.openxmlformats.org/drawingml/2006/main">
             <a:fillRect l="0" t="0" r="0" b="0"/>
@@ -5894,7 +5914,7 @@
                 <a:ea typeface="Arial"/>
                 <a:cs typeface="Arial"/>
               </a:rPr>
-              <a:t>Stronger evidence changed the conclusion, and that is useful progress</a:t>
+              <a:t>Corrected labels align the pilot and full-pass evidence</a:t>
             </a:r>
           </a:p>
         </p:txBody>
@@ -6214,51 +6234,7 @@
                 <a:ea typeface="Arial"/>
                 <a:cs typeface="Arial"/>
               </a:rPr>
-              <a:t>Early development result: </a:t>
-            </a:r>
-            <a:r>
-              <a:rPr sz="1800">
-                <a:solidFill>
-                  <a:srgbClr val="F7FAFC"/>
-                </a:solidFill>
-                <a:latin typeface="Arial"/>
-                <a:ea typeface="Arial"/>
-                <a:cs typeface="Arial"/>
-              </a:rPr>
-              <a:t>E1</a:t>
-            </a:r>
-            <a:r>
-              <a:rPr sz="1800">
-                <a:solidFill>
-                  <a:srgbClr val="F7FAFC"/>
-                </a:solidFill>
-                <a:latin typeface="Arial"/>
-                <a:ea typeface="Arial"/>
-                <a:cs typeface="Arial"/>
-              </a:rPr>
-              <a:t> AP50 0.0692 versus </a:t>
-            </a:r>
-            <a:r>
-              <a:rPr sz="1800">
-                <a:solidFill>
-                  <a:srgbClr val="F7FAFC"/>
-                </a:solidFill>
-                <a:latin typeface="Arial"/>
-                <a:ea typeface="Arial"/>
-                <a:cs typeface="Arial"/>
-              </a:rPr>
-              <a:t>E2</a:t>
-            </a:r>
-            <a:r>
-              <a:rPr sz="1800">
-                <a:solidFill>
-                  <a:srgbClr val="F7FAFC"/>
-                </a:solidFill>
-                <a:latin typeface="Arial"/>
-                <a:ea typeface="Arial"/>
-                <a:cs typeface="Arial"/>
-              </a:rPr>
-              <a:t> 0.0120.</a:t>
+              <a:t>Early development result: E2 AP50 0.0692 versus E1 0.0120.</a:t>
             </a:r>
           </a:p>
           <a:p xmlns:a="http://schemas.openxmlformats.org/drawingml/2006/main">
@@ -6546,40 +6522,7 @@
                 <a:ea typeface="Arial"/>
                 <a:cs typeface="Arial"/>
               </a:rPr>
-              <a:t>E2</a:t>
-            </a:r>
-            <a:r>
-              <a:rPr sz="1800">
-                <a:solidFill>
-                  <a:srgbClr val="F7FAFC"/>
-                </a:solidFill>
-                <a:latin typeface="Arial"/>
-                <a:ea typeface="Arial"/>
-                <a:cs typeface="Arial"/>
-              </a:rPr>
-              <a:t> reached AP50 0.1698 and led jointly trained </a:t>
-            </a:r>
-            <a:r>
-              <a:rPr sz="1800">
-                <a:solidFill>
-                  <a:srgbClr val="F7FAFC"/>
-                </a:solidFill>
-                <a:latin typeface="Arial"/>
-                <a:ea typeface="Arial"/>
-                <a:cs typeface="Arial"/>
-              </a:rPr>
-              <a:t>E1</a:t>
-            </a:r>
-            <a:r>
-              <a:rPr sz="1800">
-                <a:solidFill>
-                  <a:srgbClr val="F7FAFC"/>
-                </a:solidFill>
-                <a:latin typeface="Arial"/>
-                <a:ea typeface="Arial"/>
-                <a:cs typeface="Arial"/>
-              </a:rPr>
-              <a:t> at 0.1146.</a:t>
+              <a:t>E2 image + state reached AP50 0.1698 and led image-only E1 at 0.1146.</a:t>
             </a:r>
           </a:p>
           <a:p xmlns:a="http://schemas.openxmlformats.org/drawingml/2006/main">
@@ -6606,7 +6549,7 @@
                 <a:ea typeface="Arial"/>
                 <a:cs typeface="Arial"/>
               </a:rPr>
-              <a:t>Stress tests identified visual-weight drift in E2.</a:t>
+              <a:t>Stress tests documented the E2 state path under controlled interventions.</a:t>
             </a:r>
           </a:p>
           <a:p xmlns:a="http://schemas.openxmlformats.org/drawingml/2006/main">
@@ -6633,7 +6576,7 @@
                 <a:ea typeface="Arial"/>
                 <a:cs typeface="Arial"/>
               </a:rPr>
-              <a:t>E4 recovered to AP50 0.1697, but flight state still gave no reliable gain.</a:t>
+              <a:t>E4 reached AP50 0.1697 but did not improve on E2.</a:t>
             </a:r>
           </a:p>
         </p:txBody>
@@ -6691,29 +6634,7 @@
                 <a:ea typeface="Arial"/>
                 <a:cs typeface="Arial"/>
               </a:rPr>
-              <a:t>Review 2 replaced an early promise with a tested decision: keep </a:t>
-            </a:r>
-            <a:r>
-              <a:rPr sz="1650" b="1" i="0">
-                <a:solidFill>
-                  <a:srgbClr val="38D39F"/>
-                </a:solidFill>
-                <a:latin typeface="Arial"/>
-                <a:ea typeface="Arial"/>
-                <a:cs typeface="Arial"/>
-              </a:rPr>
-              <a:t>E2</a:t>
-            </a:r>
-            <a:r>
-              <a:rPr sz="1650" b="1" i="0">
-                <a:solidFill>
-                  <a:srgbClr val="38D39F"/>
-                </a:solidFill>
-                <a:latin typeface="Arial"/>
-                <a:ea typeface="Arial"/>
-                <a:cs typeface="Arial"/>
-              </a:rPr>
-              <a:t>.</a:t>
+              <a:t>Review 2 confirmed E2 image + state as the development leader.</a:t>
             </a:r>
           </a:p>
         </p:txBody>
@@ -7018,7 +6939,7 @@
           <p:nvPr/>
         </p:nvPicPr>
         <p:blipFill>
-          <a:blip xmlns:r="http://schemas.openxmlformats.org/officeDocument/2006/relationships" xmlns:a="http://schemas.openxmlformats.org/drawingml/2006/main" r:embed="Rcb4fd239174d4e88"/>
+          <a:blip xmlns:r="http://schemas.openxmlformats.org/officeDocument/2006/relationships" xmlns:a="http://schemas.openxmlformats.org/drawingml/2006/main" r:embed="Rd96905a4375048bf"/>
           <a:stretch xmlns:a="http://schemas.openxmlformats.org/drawingml/2006/main"/>
         </p:blipFill>
         <p:spPr>
@@ -7737,7 +7658,7 @@
           <p:nvPr/>
         </p:nvPicPr>
         <p:blipFill>
-          <a:blip xmlns:r="http://schemas.openxmlformats.org/officeDocument/2006/relationships" xmlns:a="http://schemas.openxmlformats.org/drawingml/2006/main" r:embed="Rbfdf85c1c9584510"/>
+          <a:blip xmlns:r="http://schemas.openxmlformats.org/officeDocument/2006/relationships" xmlns:a="http://schemas.openxmlformats.org/drawingml/2006/main" r:embed="R865cb2f7268146d0"/>
           <a:stretch xmlns:a="http://schemas.openxmlformats.org/drawingml/2006/main"/>
         </p:blipFill>
         <p:spPr>
@@ -7803,18 +7724,7 @@
                 <a:ea typeface="Arial"/>
                 <a:cs typeface="Arial"/>
               </a:rPr>
-              <a:t>E2</a:t>
-            </a:r>
-            <a:r>
-              <a:rPr sz="1500" b="1" i="0">
-                <a:solidFill>
-                  <a:srgbClr val="2CC7DF"/>
-                </a:solidFill>
-                <a:latin typeface="Arial"/>
-                <a:ea typeface="Arial"/>
-                <a:cs typeface="Arial"/>
-              </a:rPr>
-              <a:t> image only</a:t>
+              <a:t>E1 image only</a:t>
             </a:r>
           </a:p>
         </p:txBody>
@@ -7872,18 +7782,7 @@
                 <a:ea typeface="Arial"/>
                 <a:cs typeface="Arial"/>
               </a:rPr>
-              <a:t>E1</a:t>
-            </a:r>
-            <a:r>
-              <a:rPr sz="1500" b="1" i="0">
-                <a:solidFill>
-                  <a:srgbClr val="F6A20A"/>
-                </a:solidFill>
-                <a:latin typeface="Arial"/>
-                <a:ea typeface="Arial"/>
-                <a:cs typeface="Arial"/>
-              </a:rPr>
-              <a:t> joint image + state</a:t>
+              <a:t>E2 joint image + state</a:t>
             </a:r>
           </a:p>
         </p:txBody>
@@ -8348,11 +8247,8 @@
           <p:nvPr/>
         </p:nvPicPr>
         <p:blipFill>
-          <a:blip xmlns:r="http://schemas.openxmlformats.org/officeDocument/2006/relationships" xmlns:a="http://schemas.openxmlformats.org/drawingml/2006/main" r:embed="R467542f683c3446a"/>
-          <a:srcRect xmlns:a="http://schemas.openxmlformats.org/drawingml/2006/main" l="0" t="0" r="0" b="0"/>
-          <a:stretch xmlns:a="http://schemas.openxmlformats.org/drawingml/2006/main">
-            <a:fillRect l="0" t="0" r="0" b="0"/>
-          </a:stretch>
+          <a:blip xmlns:r="http://schemas.openxmlformats.org/officeDocument/2006/relationships" xmlns:a="http://schemas.openxmlformats.org/drawingml/2006/main" r:embed="R5c62bd7e8ff24ae3"/>
+          <a:stretch xmlns:a="http://schemas.openxmlformats.org/drawingml/2006/main"/>
         </p:blipFill>
         <p:spPr>
           <a:xfrm xmlns:a="http://schemas.openxmlformats.org/drawingml/2006/main">
@@ -8708,29 +8604,7 @@
                 <a:ea typeface="Arial"/>
                 <a:cs typeface="Arial"/>
               </a:rPr>
-              <a:t>The frozen-visual E4 run recovered </a:t>
-            </a:r>
-            <a:r>
-              <a:rPr sz="1575" b="0" i="0">
-                <a:solidFill>
-                  <a:srgbClr val="AFC0D4"/>
-                </a:solidFill>
-                <a:latin typeface="Arial"/>
-                <a:ea typeface="Arial"/>
-                <a:cs typeface="Arial"/>
-              </a:rPr>
-              <a:t>E2</a:t>
-            </a:r>
-            <a:r>
-              <a:rPr sz="1575" b="0" i="0">
-                <a:solidFill>
-                  <a:srgbClr val="AFC0D4"/>
-                </a:solidFill>
-                <a:latin typeface="Arial"/>
-                <a:ea typeface="Arial"/>
-                <a:cs typeface="Arial"/>
-              </a:rPr>
-              <a:t> performance but did not beat it</a:t>
+              <a:t>E2 leads; E4 nearly matches but does not improve on it</a:t>
             </a:r>
           </a:p>
         </p:txBody>
@@ -8860,11 +8734,8 @@
           <p:nvPr/>
         </p:nvPicPr>
         <p:blipFill>
-          <a:blip xmlns:r="http://schemas.openxmlformats.org/officeDocument/2006/relationships" xmlns:a="http://schemas.openxmlformats.org/drawingml/2006/main" r:embed="Rb76c926e449a4801"/>
-          <a:srcRect xmlns:a="http://schemas.openxmlformats.org/drawingml/2006/main" l="0" t="0" r="0" b="0"/>
-          <a:stretch xmlns:a="http://schemas.openxmlformats.org/drawingml/2006/main">
-            <a:fillRect l="0" t="0" r="0" b="0"/>
-          </a:stretch>
+          <a:blip xmlns:r="http://schemas.openxmlformats.org/officeDocument/2006/relationships" xmlns:a="http://schemas.openxmlformats.org/drawingml/2006/main" r:embed="Rf7422f5845cb44bc"/>
+          <a:stretch xmlns:a="http://schemas.openxmlformats.org/drawingml/2006/main"/>
         </p:blipFill>
         <p:spPr>
           <a:xfrm xmlns:a="http://schemas.openxmlformats.org/drawingml/2006/main">
@@ -10501,7 +10372,7 @@
           <p:nvPr/>
         </p:nvPicPr>
         <p:blipFill>
-          <a:blip xmlns:r="http://schemas.openxmlformats.org/officeDocument/2006/relationships" xmlns:a="http://schemas.openxmlformats.org/drawingml/2006/main" r:embed="Rc7971b38f96f4ce4"/>
+          <a:blip xmlns:r="http://schemas.openxmlformats.org/officeDocument/2006/relationships" xmlns:a="http://schemas.openxmlformats.org/drawingml/2006/main" r:embed="R0749c4fffab14b78"/>
           <a:stretch xmlns:a="http://schemas.openxmlformats.org/drawingml/2006/main"/>
         </p:blipFill>
         <p:spPr>

</xml_diff>